<commit_message>
asses a few slides
</commit_message>
<xml_diff>
--- a/Slides/JavaScript/09 - Accessing DOM elements.pptx
+++ b/Slides/JavaScript/09 - Accessing DOM elements.pptx
@@ -5,10 +5,10 @@
     <p:sldMasterId id="2147483648" r:id="rId4"/>
   </p:sldMasterIdLst>
   <p:notesMasterIdLst>
-    <p:notesMasterId r:id="rId20"/>
+    <p:notesMasterId r:id="rId21"/>
   </p:notesMasterIdLst>
   <p:handoutMasterIdLst>
-    <p:handoutMasterId r:id="rId21"/>
+    <p:handoutMasterId r:id="rId22"/>
   </p:handoutMasterIdLst>
   <p:sldIdLst>
     <p:sldId id="263" r:id="rId5"/>
@@ -18,19 +18,20 @@
     <p:sldId id="454" r:id="rId9"/>
     <p:sldId id="455" r:id="rId10"/>
     <p:sldId id="536" r:id="rId11"/>
-    <p:sldId id="539" r:id="rId12"/>
-    <p:sldId id="540" r:id="rId13"/>
-    <p:sldId id="537" r:id="rId14"/>
-    <p:sldId id="541" r:id="rId15"/>
-    <p:sldId id="538" r:id="rId16"/>
-    <p:sldId id="542" r:id="rId17"/>
-    <p:sldId id="492" r:id="rId18"/>
-    <p:sldId id="534" r:id="rId19"/>
+    <p:sldId id="923" r:id="rId12"/>
+    <p:sldId id="539" r:id="rId13"/>
+    <p:sldId id="540" r:id="rId14"/>
+    <p:sldId id="537" r:id="rId15"/>
+    <p:sldId id="541" r:id="rId16"/>
+    <p:sldId id="538" r:id="rId17"/>
+    <p:sldId id="542" r:id="rId18"/>
+    <p:sldId id="492" r:id="rId19"/>
+    <p:sldId id="534" r:id="rId20"/>
   </p:sldIdLst>
   <p:sldSz cx="12192000" cy="6858000"/>
   <p:notesSz cx="6645275" cy="9775825"/>
   <p:custDataLst>
-    <p:tags r:id="rId22"/>
+    <p:tags r:id="rId23"/>
   </p:custDataLst>
   <p:defaultTextStyle>
     <a:defPPr>
@@ -251,7 +252,7 @@
             <a:fld id="{86D088FE-3E68-47FE-8BA4-634CD34BABBC}" type="datetimeFigureOut">
               <a:rPr lang="en-GB" smtClean="0"/>
               <a:pPr/>
-              <a:t>03/06/2025</a:t>
+              <a:t>20/05/2026</a:t>
             </a:fld>
             <a:endParaRPr lang="en-GB"/>
           </a:p>
@@ -423,7 +424,7 @@
             <a:fld id="{1D6B66C6-1E92-0F4E-A300-9D4ED1F0C23F}" type="datetimeFigureOut">
               <a:rPr lang="en-GB" smtClean="0"/>
               <a:pPr/>
-              <a:t>03/06/2025</a:t>
+              <a:t>20/05/2026</a:t>
             </a:fld>
             <a:endParaRPr lang="en-GB"/>
           </a:p>
@@ -812,38 +813,52 @@
       </p:grpSpPr>
       <p:sp>
         <p:nvSpPr>
-          <p:cNvPr id="2" name="Slide Image Placeholder 1"/>
+          <p:cNvPr id="44034" name="Rectangle 2"/>
           <p:cNvSpPr>
-            <a:spLocks noGrp="1" noRot="1" noChangeAspect="1"/>
-          </p:cNvSpPr>
-          <p:nvPr>
-            <p:ph type="sldImg"/>
-          </p:nvPr>
-        </p:nvSpPr>
-        <p:spPr/>
-      </p:sp>
-      <p:sp>
-        <p:nvSpPr>
-          <p:cNvPr id="3" name="Notes Placeholder 2"/>
-          <p:cNvSpPr>
-            <a:spLocks noGrp="1"/>
+            <a:spLocks noGrp="1" noChangeArrowheads="1"/>
           </p:cNvSpPr>
           <p:nvPr>
             <p:ph type="body" idx="1"/>
           </p:nvPr>
         </p:nvSpPr>
-        <p:spPr/>
+        <p:spPr>
+          <a:noFill/>
+          <a:ln/>
+        </p:spPr>
         <p:txBody>
           <a:bodyPr/>
           <a:lstStyle/>
           <a:p>
-            <a:endParaRPr lang="en-IN"/>
+            <a:pPr defTabSz="739775">
+              <a:tabLst/>
+            </a:pPr>
+            <a:endParaRPr lang="en-GB" dirty="0"/>
           </a:p>
         </p:txBody>
       </p:sp>
       <p:sp>
         <p:nvSpPr>
-          <p:cNvPr id="4" name="Slide Number Placeholder 3"/>
+          <p:cNvPr id="44035" name="Slide"/>
+          <p:cNvSpPr>
+            <a:spLocks noGrp="1" noRot="1" noChangeAspect="1" noChangeArrowheads="1" noTextEdit="1"/>
+          </p:cNvSpPr>
+          <p:nvPr>
+            <p:ph type="sldImg" idx="2"/>
+          </p:nvPr>
+        </p:nvSpPr>
+        <p:spPr>
+          <a:ln/>
+        </p:spPr>
+      </p:sp>
+      <p:sp>
+        <p:nvSpPr>
+          <p:cNvPr id="2" name="Slide Number Placeholder 1">
+            <a:extLst>
+              <a:ext uri="{FF2B5EF4-FFF2-40B4-BE49-F238E27FC236}">
+                <a16:creationId xmlns:a16="http://schemas.microsoft.com/office/drawing/2014/main" id="{0B370DB1-7E1A-4D93-A9C6-214D46F2239E}"/>
+              </a:ext>
+            </a:extLst>
+          </p:cNvPr>
           <p:cNvSpPr>
             <a:spLocks noGrp="1"/>
           </p:cNvSpPr>
@@ -859,7 +874,7 @@
             <a:fld id="{548901C6-1DA1-FB44-ABEE-06A0FEB7738E}" type="slidenum">
               <a:rPr lang="en-GB" smtClean="0"/>
               <a:pPr/>
-              <a:t>14</a:t>
+              <a:t>10</a:t>
             </a:fld>
             <a:endParaRPr lang="en-GB"/>
           </a:p>
@@ -868,7 +883,7 @@
     </p:spTree>
     <p:extLst>
       <p:ext uri="{BB962C8B-B14F-4D97-AF65-F5344CB8AC3E}">
-        <p14:creationId xmlns:p14="http://schemas.microsoft.com/office/powerpoint/2010/main" val="2087235477"/>
+        <p14:creationId xmlns:p14="http://schemas.microsoft.com/office/powerpoint/2010/main" val="3914971605"/>
       </p:ext>
     </p:extLst>
   </p:cSld>
@@ -945,6 +960,91 @@
               <a:rPr lang="en-GB" smtClean="0"/>
               <a:pPr/>
               <a:t>15</a:t>
+            </a:fld>
+            <a:endParaRPr lang="en-GB"/>
+          </a:p>
+        </p:txBody>
+      </p:sp>
+    </p:spTree>
+    <p:extLst>
+      <p:ext uri="{BB962C8B-B14F-4D97-AF65-F5344CB8AC3E}">
+        <p14:creationId xmlns:p14="http://schemas.microsoft.com/office/powerpoint/2010/main" val="2087235477"/>
+      </p:ext>
+    </p:extLst>
+  </p:cSld>
+  <p:clrMapOvr>
+    <a:masterClrMapping/>
+  </p:clrMapOvr>
+</p:notes>
+</file>
+
+<file path=ppt/notesSlides/notesSlide12.xml><?xml version="1.0" encoding="utf-8"?>
+<p:notes xmlns:a="http://schemas.openxmlformats.org/drawingml/2006/main" xmlns:r="http://schemas.openxmlformats.org/officeDocument/2006/relationships" xmlns:p="http://schemas.openxmlformats.org/presentationml/2006/main">
+  <p:cSld>
+    <p:spTree>
+      <p:nvGrpSpPr>
+        <p:cNvPr id="1" name=""/>
+        <p:cNvGrpSpPr/>
+        <p:nvPr/>
+      </p:nvGrpSpPr>
+      <p:grpSpPr>
+        <a:xfrm>
+          <a:off x="0" y="0"/>
+          <a:ext cx="0" cy="0"/>
+          <a:chOff x="0" y="0"/>
+          <a:chExt cx="0" cy="0"/>
+        </a:xfrm>
+      </p:grpSpPr>
+      <p:sp>
+        <p:nvSpPr>
+          <p:cNvPr id="2" name="Slide Image Placeholder 1"/>
+          <p:cNvSpPr>
+            <a:spLocks noGrp="1" noRot="1" noChangeAspect="1"/>
+          </p:cNvSpPr>
+          <p:nvPr>
+            <p:ph type="sldImg"/>
+          </p:nvPr>
+        </p:nvSpPr>
+        <p:spPr/>
+      </p:sp>
+      <p:sp>
+        <p:nvSpPr>
+          <p:cNvPr id="3" name="Notes Placeholder 2"/>
+          <p:cNvSpPr>
+            <a:spLocks noGrp="1"/>
+          </p:cNvSpPr>
+          <p:nvPr>
+            <p:ph type="body" idx="1"/>
+          </p:nvPr>
+        </p:nvSpPr>
+        <p:spPr/>
+        <p:txBody>
+          <a:bodyPr/>
+          <a:lstStyle/>
+          <a:p>
+            <a:endParaRPr lang="en-IN"/>
+          </a:p>
+        </p:txBody>
+      </p:sp>
+      <p:sp>
+        <p:nvSpPr>
+          <p:cNvPr id="4" name="Slide Number Placeholder 3"/>
+          <p:cNvSpPr>
+            <a:spLocks noGrp="1"/>
+          </p:cNvSpPr>
+          <p:nvPr>
+            <p:ph type="sldNum" sz="quarter" idx="5"/>
+          </p:nvPr>
+        </p:nvSpPr>
+        <p:spPr/>
+        <p:txBody>
+          <a:bodyPr/>
+          <a:lstStyle/>
+          <a:p>
+            <a:fld id="{548901C6-1DA1-FB44-ABEE-06A0FEB7738E}" type="slidenum">
+              <a:rPr lang="en-GB" smtClean="0"/>
+              <a:pPr/>
+              <a:t>16</a:t>
             </a:fld>
             <a:endParaRPr lang="en-GB"/>
           </a:p>
@@ -1907,52 +2007,43 @@
       </p:grpSpPr>
       <p:sp>
         <p:nvSpPr>
-          <p:cNvPr id="44034" name="Rectangle 2"/>
+          <p:cNvPr id="2" name="Slide Image Placeholder 1"/>
           <p:cNvSpPr>
-            <a:spLocks noGrp="1" noChangeArrowheads="1"/>
+            <a:spLocks noGrp="1" noRot="1" noChangeAspect="1"/>
+          </p:cNvSpPr>
+          <p:nvPr>
+            <p:ph type="sldImg"/>
+          </p:nvPr>
+        </p:nvSpPr>
+        <p:spPr>
+          <a:xfrm>
+            <a:off x="571500" y="581025"/>
+            <a:ext cx="5715000" cy="3216275"/>
+          </a:xfrm>
+        </p:spPr>
+      </p:sp>
+      <p:sp>
+        <p:nvSpPr>
+          <p:cNvPr id="3" name="Notes Placeholder 2"/>
+          <p:cNvSpPr>
+            <a:spLocks noGrp="1"/>
           </p:cNvSpPr>
           <p:nvPr>
             <p:ph type="body" idx="1"/>
           </p:nvPr>
         </p:nvSpPr>
-        <p:spPr>
-          <a:noFill/>
-          <a:ln/>
-        </p:spPr>
+        <p:spPr/>
         <p:txBody>
           <a:bodyPr/>
           <a:lstStyle/>
           <a:p>
-            <a:pPr defTabSz="739775">
-              <a:tabLst/>
-            </a:pPr>
             <a:endParaRPr lang="en-GB" dirty="0"/>
           </a:p>
         </p:txBody>
       </p:sp>
       <p:sp>
         <p:nvSpPr>
-          <p:cNvPr id="44035" name="Slide"/>
-          <p:cNvSpPr>
-            <a:spLocks noGrp="1" noRot="1" noChangeAspect="1" noChangeArrowheads="1" noTextEdit="1"/>
-          </p:cNvSpPr>
-          <p:nvPr>
-            <p:ph type="sldImg" idx="2"/>
-          </p:nvPr>
-        </p:nvSpPr>
-        <p:spPr>
-          <a:ln/>
-        </p:spPr>
-      </p:sp>
-      <p:sp>
-        <p:nvSpPr>
-          <p:cNvPr id="2" name="Slide Number Placeholder 1">
-            <a:extLst>
-              <a:ext uri="{FF2B5EF4-FFF2-40B4-BE49-F238E27FC236}">
-                <a16:creationId xmlns:a16="http://schemas.microsoft.com/office/drawing/2014/main" id="{0B370DB1-7E1A-4D93-A9C6-214D46F2239E}"/>
-              </a:ext>
-            </a:extLst>
-          </p:cNvPr>
+          <p:cNvPr id="4" name="Slide Number Placeholder 3"/>
           <p:cNvSpPr>
             <a:spLocks noGrp="1"/>
           </p:cNvSpPr>
@@ -1965,19 +2056,28 @@
           <a:bodyPr/>
           <a:lstStyle/>
           <a:p>
-            <a:fld id="{548901C6-1DA1-FB44-ABEE-06A0FEB7738E}" type="slidenum">
-              <a:rPr lang="en-GB" smtClean="0"/>
-              <a:pPr/>
+            <a:pPr>
+              <a:defRPr/>
+            </a:pPr>
+            <a:r>
+              <a:rPr lang="en-GB"/>
+              <a:t>CONTINUED </a:t>
+            </a:r>
+            <a:fld id="{993982D2-741D-4BC6-8F8E-84F7C8891268}" type="slidenum">
+              <a:rPr smtClean="0"/>
+              <a:pPr>
+                <a:defRPr/>
+              </a:pPr>
               <a:t>8</a:t>
             </a:fld>
-            <a:endParaRPr lang="en-GB"/>
+            <a:endParaRPr dirty="0"/>
           </a:p>
         </p:txBody>
       </p:sp>
     </p:spTree>
     <p:extLst>
       <p:ext uri="{BB962C8B-B14F-4D97-AF65-F5344CB8AC3E}">
-        <p14:creationId xmlns:p14="http://schemas.microsoft.com/office/powerpoint/2010/main" val="3456613372"/>
+        <p14:creationId xmlns:p14="http://schemas.microsoft.com/office/powerpoint/2010/main" val="1513863224"/>
       </p:ext>
     </p:extLst>
   </p:cSld>
@@ -2076,7 +2176,7 @@
     </p:spTree>
     <p:extLst>
       <p:ext uri="{BB962C8B-B14F-4D97-AF65-F5344CB8AC3E}">
-        <p14:creationId xmlns:p14="http://schemas.microsoft.com/office/powerpoint/2010/main" val="3914971605"/>
+        <p14:creationId xmlns:p14="http://schemas.microsoft.com/office/powerpoint/2010/main" val="3456613372"/>
       </p:ext>
     </p:extLst>
   </p:cSld>
@@ -2155,13 +2255,13 @@
           <p:nvPr userDrawn="1"/>
         </p:nvPicPr>
         <p:blipFill>
-          <a:blip r:embed="rId3">
+          <a:blip>
             <a:extLst>
               <a:ext uri="{28A0092B-C50C-407E-A947-70E740481C1C}">
                 <a14:useLocalDpi xmlns:a14="http://schemas.microsoft.com/office/drawing/2010/main" val="0"/>
               </a:ext>
               <a:ext uri="{96DAC541-7B7A-43D3-8B79-37D633B846F1}">
-                <asvg:svgBlip xmlns:asvg="http://schemas.microsoft.com/office/drawing/2016/SVG/main" r:embed="rId4"/>
+                <asvg:svgBlip xmlns:asvg="http://schemas.microsoft.com/office/drawing/2016/SVG/main" r:embed="rId3"/>
               </a:ext>
             </a:extLst>
           </a:blip>
@@ -10542,13 +10642,13 @@
           <p:nvPr userDrawn="1"/>
         </p:nvPicPr>
         <p:blipFill>
-          <a:blip r:embed="rId3">
+          <a:blip>
             <a:extLst>
               <a:ext uri="{28A0092B-C50C-407E-A947-70E740481C1C}">
                 <a14:useLocalDpi xmlns:a14="http://schemas.microsoft.com/office/drawing/2010/main" val="0"/>
               </a:ext>
               <a:ext uri="{96DAC541-7B7A-43D3-8B79-37D633B846F1}">
-                <asvg:svgBlip xmlns:asvg="http://schemas.microsoft.com/office/drawing/2016/SVG/main" r:embed="rId4"/>
+                <asvg:svgBlip xmlns:asvg="http://schemas.microsoft.com/office/drawing/2016/SVG/main" r:embed="rId3"/>
               </a:ext>
             </a:extLst>
           </a:blip>
@@ -17719,13 +17819,13 @@
           <p:nvPr userDrawn="1"/>
         </p:nvPicPr>
         <p:blipFill>
-          <a:blip r:embed="rId3">
+          <a:blip>
             <a:extLst>
               <a:ext uri="{28A0092B-C50C-407E-A947-70E740481C1C}">
                 <a14:useLocalDpi xmlns:a14="http://schemas.microsoft.com/office/drawing/2010/main" val="0"/>
               </a:ext>
               <a:ext uri="{96DAC541-7B7A-43D3-8B79-37D633B846F1}">
-                <asvg:svgBlip xmlns:asvg="http://schemas.microsoft.com/office/drawing/2016/SVG/main" r:embed="rId4"/>
+                <asvg:svgBlip xmlns:asvg="http://schemas.microsoft.com/office/drawing/2016/SVG/main" r:embed="rId3"/>
               </a:ext>
             </a:extLst>
           </a:blip>
@@ -20346,13 +20446,13 @@
           <p:nvPr userDrawn="1"/>
         </p:nvPicPr>
         <p:blipFill>
-          <a:blip r:embed="rId3">
+          <a:blip>
             <a:extLst>
               <a:ext uri="{28A0092B-C50C-407E-A947-70E740481C1C}">
                 <a14:useLocalDpi xmlns:a14="http://schemas.microsoft.com/office/drawing/2010/main" val="0"/>
               </a:ext>
               <a:ext uri="{96DAC541-7B7A-43D3-8B79-37D633B846F1}">
-                <asvg:svgBlip xmlns:asvg="http://schemas.microsoft.com/office/drawing/2016/SVG/main" r:embed="rId4"/>
+                <asvg:svgBlip xmlns:asvg="http://schemas.microsoft.com/office/drawing/2016/SVG/main" r:embed="rId3"/>
               </a:ext>
             </a:extLst>
           </a:blip>
@@ -21642,13 +21742,13 @@
           <p:nvPr userDrawn="1"/>
         </p:nvPicPr>
         <p:blipFill>
-          <a:blip r:embed="rId3">
+          <a:blip>
             <a:extLst>
               <a:ext uri="{28A0092B-C50C-407E-A947-70E740481C1C}">
                 <a14:useLocalDpi xmlns:a14="http://schemas.microsoft.com/office/drawing/2010/main" val="0"/>
               </a:ext>
               <a:ext uri="{96DAC541-7B7A-43D3-8B79-37D633B846F1}">
-                <asvg:svgBlip xmlns:asvg="http://schemas.microsoft.com/office/drawing/2016/SVG/main" r:embed="rId4"/>
+                <asvg:svgBlip xmlns:asvg="http://schemas.microsoft.com/office/drawing/2016/SVG/main" r:embed="rId3"/>
               </a:ext>
             </a:extLst>
           </a:blip>
@@ -26378,6 +26478,913 @@
       </p:grpSpPr>
       <p:sp>
         <p:nvSpPr>
+          <p:cNvPr id="18434" name="Rectangle 5"/>
+          <p:cNvSpPr>
+            <a:spLocks noGrp="1" noChangeArrowheads="1"/>
+          </p:cNvSpPr>
+          <p:nvPr>
+            <p:ph type="title"/>
+          </p:nvPr>
+        </p:nvSpPr>
+        <p:spPr/>
+        <p:txBody>
+          <a:bodyPr/>
+          <a:lstStyle/>
+          <a:p>
+            <a:r>
+              <a:rPr lang="en-US" dirty="0"/>
+              <a:t>Changing multiple styles of an element</a:t>
+            </a:r>
+          </a:p>
+        </p:txBody>
+      </p:sp>
+      <p:sp>
+        <p:nvSpPr>
+          <p:cNvPr id="18435" name="Rectangle 6"/>
+          <p:cNvSpPr>
+            <a:spLocks noGrp="1" noChangeArrowheads="1"/>
+          </p:cNvSpPr>
+          <p:nvPr>
+            <p:ph idx="1"/>
+          </p:nvPr>
+        </p:nvSpPr>
+        <p:spPr/>
+        <p:txBody>
+          <a:bodyPr/>
+          <a:lstStyle/>
+          <a:p>
+            <a:pPr marL="684000" lvl="1" indent="-342000">
+              <a:buFont typeface="Arial" panose="020B0604020202020204" pitchFamily="34" charset="0"/>
+              <a:buChar char="•"/>
+            </a:pPr>
+            <a:endParaRPr lang="en-GB" dirty="0">
+              <a:latin typeface="Arial" charset="0"/>
+              <a:ea typeface="Arial" charset="0"/>
+              <a:cs typeface="Arial" charset="0"/>
+            </a:endParaRPr>
+          </a:p>
+          <a:p>
+            <a:pPr marL="684000" lvl="1" indent="-342000">
+              <a:buFont typeface="Arial" panose="020B0604020202020204" pitchFamily="34" charset="0"/>
+              <a:buChar char="•"/>
+            </a:pPr>
+            <a:endParaRPr lang="en-GB" dirty="0">
+              <a:latin typeface="Arial" charset="0"/>
+              <a:ea typeface="Arial" charset="0"/>
+              <a:cs typeface="Arial" charset="0"/>
+            </a:endParaRPr>
+          </a:p>
+          <a:p>
+            <a:pPr marL="684000" lvl="1" indent="-342000">
+              <a:buFont typeface="Arial" panose="020B0604020202020204" pitchFamily="34" charset="0"/>
+              <a:buChar char="•"/>
+            </a:pPr>
+            <a:endParaRPr lang="en-GB" dirty="0">
+              <a:latin typeface="Arial" charset="0"/>
+              <a:ea typeface="Arial" charset="0"/>
+              <a:cs typeface="Arial" charset="0"/>
+            </a:endParaRPr>
+          </a:p>
+          <a:p>
+            <a:pPr marL="684000" lvl="1" indent="-342000">
+              <a:buFont typeface="Arial" panose="020B0604020202020204" pitchFamily="34" charset="0"/>
+              <a:buChar char="•"/>
+            </a:pPr>
+            <a:endParaRPr lang="en-GB" dirty="0">
+              <a:latin typeface="Arial" charset="0"/>
+              <a:ea typeface="Arial" charset="0"/>
+              <a:cs typeface="Arial" charset="0"/>
+            </a:endParaRPr>
+          </a:p>
+          <a:p>
+            <a:pPr marL="684000" lvl="1" indent="-342000">
+              <a:buFont typeface="Arial" panose="020B0604020202020204" pitchFamily="34" charset="0"/>
+              <a:buChar char="•"/>
+            </a:pPr>
+            <a:endParaRPr lang="en-GB" dirty="0">
+              <a:latin typeface="Arial" charset="0"/>
+              <a:ea typeface="Arial" charset="0"/>
+              <a:cs typeface="Arial" charset="0"/>
+            </a:endParaRPr>
+          </a:p>
+          <a:p>
+            <a:pPr marL="684000" lvl="1" indent="-342000">
+              <a:buFont typeface="Arial" panose="020B0604020202020204" pitchFamily="34" charset="0"/>
+              <a:buChar char="•"/>
+            </a:pPr>
+            <a:endParaRPr lang="en-GB" dirty="0">
+              <a:latin typeface="Arial" charset="0"/>
+              <a:ea typeface="Arial" charset="0"/>
+              <a:cs typeface="Arial" charset="0"/>
+            </a:endParaRPr>
+          </a:p>
+          <a:p>
+            <a:pPr marL="684000" lvl="1" indent="-342000">
+              <a:buFont typeface="Arial" panose="020B0604020202020204" pitchFamily="34" charset="0"/>
+              <a:buChar char="•"/>
+            </a:pPr>
+            <a:endParaRPr lang="en-GB" dirty="0">
+              <a:latin typeface="Arial" charset="0"/>
+              <a:ea typeface="Arial" charset="0"/>
+              <a:cs typeface="Arial" charset="0"/>
+            </a:endParaRPr>
+          </a:p>
+          <a:p>
+            <a:pPr marL="684000" lvl="1" indent="-342000">
+              <a:buSzPct val="115000"/>
+              <a:buFont typeface="Arial" panose="020B0604020202020204" pitchFamily="34" charset="0"/>
+              <a:buChar char="•"/>
+            </a:pPr>
+            <a:r>
+              <a:rPr lang="en-GB" dirty="0">
+                <a:latin typeface="+mn-lt"/>
+                <a:ea typeface="Arial" charset="0"/>
+                <a:cs typeface="Arial" charset="0"/>
+              </a:rPr>
+              <a:t>The</a:t>
+            </a:r>
+            <a:r>
+              <a:rPr lang="en-GB" dirty="0">
+                <a:latin typeface="Arial" charset="0"/>
+                <a:ea typeface="Arial" charset="0"/>
+                <a:cs typeface="Arial" charset="0"/>
+              </a:rPr>
+              <a:t> </a:t>
+            </a:r>
+            <a:r>
+              <a:rPr lang="en-GB" dirty="0" err="1">
+                <a:latin typeface="Lucida Console" charset="0"/>
+                <a:ea typeface="Lucida Console" charset="0"/>
+                <a:cs typeface="Lucida Console" charset="0"/>
+              </a:rPr>
+              <a:t>className</a:t>
+            </a:r>
+            <a:r>
+              <a:rPr lang="en-GB" dirty="0">
+                <a:latin typeface="Arial" charset="0"/>
+                <a:ea typeface="Arial" charset="0"/>
+                <a:cs typeface="Arial" charset="0"/>
+              </a:rPr>
+              <a:t> can only set a single class and it will overwrite previous classes!</a:t>
+            </a:r>
+            <a:endParaRPr lang="en-GB" dirty="0">
+              <a:latin typeface="+mn-lt"/>
+              <a:ea typeface="Arial" charset="0"/>
+              <a:cs typeface="Arial" charset="0"/>
+            </a:endParaRPr>
+          </a:p>
+          <a:p>
+            <a:pPr marL="684000" lvl="1" indent="-342000">
+              <a:buSzPct val="115000"/>
+              <a:buFont typeface="Arial" panose="020B0604020202020204" pitchFamily="34" charset="0"/>
+              <a:buChar char="•"/>
+            </a:pPr>
+            <a:r>
+              <a:rPr lang="en-GB" dirty="0" err="1">
+                <a:latin typeface="+mn-lt"/>
+                <a:ea typeface="Arial" charset="0"/>
+                <a:cs typeface="Arial" charset="0"/>
+              </a:rPr>
+              <a:t>classList</a:t>
+            </a:r>
+            <a:r>
+              <a:rPr lang="en-GB" dirty="0">
+                <a:latin typeface="+mn-lt"/>
+                <a:ea typeface="Arial" charset="0"/>
+                <a:cs typeface="Arial" charset="0"/>
+              </a:rPr>
+              <a:t> enables you to apply multiple styles by using code</a:t>
+            </a:r>
+          </a:p>
+        </p:txBody>
+      </p:sp>
+      <p:sp>
+        <p:nvSpPr>
+          <p:cNvPr id="4" name="TextBox 3">
+            <a:extLst>
+              <a:ext uri="{FF2B5EF4-FFF2-40B4-BE49-F238E27FC236}">
+                <a16:creationId xmlns:a16="http://schemas.microsoft.com/office/drawing/2014/main" id="{59248DC2-AC12-5660-A3A6-C4C067E6A4BA}"/>
+              </a:ext>
+            </a:extLst>
+          </p:cNvPr>
+          <p:cNvSpPr txBox="1"/>
+          <p:nvPr/>
+        </p:nvSpPr>
+        <p:spPr>
+          <a:xfrm>
+            <a:off x="586807" y="1517054"/>
+            <a:ext cx="7215648" cy="2031325"/>
+          </a:xfrm>
+          <a:prstGeom prst="rect">
+            <a:avLst/>
+          </a:prstGeom>
+          <a:solidFill>
+            <a:schemeClr val="accent5">
+              <a:lumMod val="20000"/>
+              <a:lumOff val="80000"/>
+            </a:schemeClr>
+          </a:solidFill>
+          <a:effectLst>
+            <a:outerShdw blurRad="50800" dist="38100" algn="l" rotWithShape="0">
+              <a:prstClr val="black">
+                <a:alpha val="40000"/>
+              </a:prstClr>
+            </a:outerShdw>
+          </a:effectLst>
+        </p:spPr>
+        <p:style>
+          <a:lnRef idx="2">
+            <a:schemeClr val="dk1"/>
+          </a:lnRef>
+          <a:fillRef idx="1">
+            <a:schemeClr val="lt1"/>
+          </a:fillRef>
+          <a:effectRef idx="0">
+            <a:schemeClr val="dk1"/>
+          </a:effectRef>
+          <a:fontRef idx="minor">
+            <a:schemeClr val="dk1"/>
+          </a:fontRef>
+        </p:style>
+        <p:txBody>
+          <a:bodyPr wrap="square">
+            <a:spAutoFit/>
+          </a:bodyPr>
+          <a:lstStyle/>
+          <a:p>
+            <a:r>
+              <a:rPr lang="en-GB" sz="1800" b="1" dirty="0">
+                <a:solidFill>
+                  <a:srgbClr val="0000FF"/>
+                </a:solidFill>
+                <a:latin typeface="Consolas" panose="020B0609020204030204" pitchFamily="49" charset="0"/>
+              </a:rPr>
+              <a:t>&lt;</a:t>
+            </a:r>
+            <a:r>
+              <a:rPr lang="en-GB" sz="1800" b="1" dirty="0">
+                <a:solidFill>
+                  <a:srgbClr val="800000"/>
+                </a:solidFill>
+                <a:latin typeface="Consolas" panose="020B0609020204030204" pitchFamily="49" charset="0"/>
+              </a:rPr>
+              <a:t>div</a:t>
+            </a:r>
+            <a:r>
+              <a:rPr lang="en-GB" sz="1800" b="1" dirty="0">
+                <a:solidFill>
+                  <a:srgbClr val="000000"/>
+                </a:solidFill>
+                <a:latin typeface="Consolas" panose="020B0609020204030204" pitchFamily="49" charset="0"/>
+              </a:rPr>
+              <a:t> </a:t>
+            </a:r>
+            <a:r>
+              <a:rPr lang="en-GB" sz="1800" b="1" dirty="0">
+                <a:solidFill>
+                  <a:srgbClr val="FF0000"/>
+                </a:solidFill>
+                <a:latin typeface="Consolas" panose="020B0609020204030204" pitchFamily="49" charset="0"/>
+              </a:rPr>
+              <a:t>id</a:t>
+            </a:r>
+            <a:r>
+              <a:rPr lang="en-GB" sz="1800" b="1" dirty="0">
+                <a:solidFill>
+                  <a:srgbClr val="0000FF"/>
+                </a:solidFill>
+                <a:latin typeface="Consolas" panose="020B0609020204030204" pitchFamily="49" charset="0"/>
+              </a:rPr>
+              <a:t>="hello"&gt;</a:t>
+            </a:r>
+            <a:r>
+              <a:rPr lang="en-GB" sz="1800" b="1" dirty="0">
+                <a:solidFill>
+                  <a:srgbClr val="000000"/>
+                </a:solidFill>
+                <a:latin typeface="Consolas" panose="020B0609020204030204" pitchFamily="49" charset="0"/>
+              </a:rPr>
+              <a:t>Hello world</a:t>
+            </a:r>
+            <a:r>
+              <a:rPr lang="en-GB" sz="1800" b="1" dirty="0">
+                <a:solidFill>
+                  <a:srgbClr val="0000FF"/>
+                </a:solidFill>
+                <a:latin typeface="Consolas" panose="020B0609020204030204" pitchFamily="49" charset="0"/>
+              </a:rPr>
+              <a:t>&lt;/</a:t>
+            </a:r>
+            <a:r>
+              <a:rPr lang="en-GB" sz="1800" b="1" dirty="0">
+                <a:solidFill>
+                  <a:srgbClr val="800000"/>
+                </a:solidFill>
+                <a:latin typeface="Consolas" panose="020B0609020204030204" pitchFamily="49" charset="0"/>
+              </a:rPr>
+              <a:t>div</a:t>
+            </a:r>
+            <a:r>
+              <a:rPr lang="en-GB" sz="1800" b="1" dirty="0">
+                <a:solidFill>
+                  <a:srgbClr val="0000FF"/>
+                </a:solidFill>
+                <a:latin typeface="Consolas" panose="020B0609020204030204" pitchFamily="49" charset="0"/>
+              </a:rPr>
+              <a:t>&gt;</a:t>
+            </a:r>
+            <a:endParaRPr lang="en-GB" sz="1800" b="1" dirty="0">
+              <a:solidFill>
+                <a:srgbClr val="000000"/>
+              </a:solidFill>
+              <a:latin typeface="Consolas" panose="020B0609020204030204" pitchFamily="49" charset="0"/>
+            </a:endParaRPr>
+          </a:p>
+          <a:p>
+            <a:endParaRPr lang="en-GB" sz="1800" b="1" dirty="0">
+              <a:solidFill>
+                <a:srgbClr val="000000"/>
+              </a:solidFill>
+              <a:latin typeface="Consolas" panose="020B0609020204030204" pitchFamily="49" charset="0"/>
+            </a:endParaRPr>
+          </a:p>
+          <a:p>
+            <a:r>
+              <a:rPr lang="en-GB" sz="1800" b="1" dirty="0">
+                <a:solidFill>
+                  <a:srgbClr val="0000FF"/>
+                </a:solidFill>
+                <a:latin typeface="Consolas" panose="020B0609020204030204" pitchFamily="49" charset="0"/>
+              </a:rPr>
+              <a:t>&lt;</a:t>
+            </a:r>
+            <a:r>
+              <a:rPr lang="en-GB" sz="1800" b="1" dirty="0">
+                <a:solidFill>
+                  <a:srgbClr val="800000"/>
+                </a:solidFill>
+                <a:latin typeface="Consolas" panose="020B0609020204030204" pitchFamily="49" charset="0"/>
+              </a:rPr>
+              <a:t>script</a:t>
+            </a:r>
+            <a:r>
+              <a:rPr lang="en-GB" sz="1800" b="1" dirty="0">
+                <a:solidFill>
+                  <a:srgbClr val="0000FF"/>
+                </a:solidFill>
+                <a:latin typeface="Consolas" panose="020B0609020204030204" pitchFamily="49" charset="0"/>
+              </a:rPr>
+              <a:t>&gt;</a:t>
+            </a:r>
+            <a:endParaRPr lang="en-GB" sz="1800" b="1" dirty="0">
+              <a:solidFill>
+                <a:srgbClr val="000000"/>
+              </a:solidFill>
+              <a:latin typeface="Consolas" panose="020B0609020204030204" pitchFamily="49" charset="0"/>
+            </a:endParaRPr>
+          </a:p>
+          <a:p>
+            <a:r>
+              <a:rPr lang="en-GB" sz="1800" b="1" dirty="0">
+                <a:solidFill>
+                  <a:srgbClr val="0000FF"/>
+                </a:solidFill>
+                <a:latin typeface="Consolas" panose="020B0609020204030204" pitchFamily="49" charset="0"/>
+              </a:rPr>
+              <a:t>    let</a:t>
+            </a:r>
+            <a:r>
+              <a:rPr lang="en-GB" sz="1800" b="1" dirty="0">
+                <a:solidFill>
+                  <a:srgbClr val="000000"/>
+                </a:solidFill>
+                <a:latin typeface="Consolas" panose="020B0609020204030204" pitchFamily="49" charset="0"/>
+              </a:rPr>
+              <a:t> div1 = </a:t>
+            </a:r>
+            <a:r>
+              <a:rPr lang="en-GB" sz="1800" b="1" dirty="0" err="1">
+                <a:solidFill>
+                  <a:srgbClr val="000000"/>
+                </a:solidFill>
+                <a:latin typeface="Consolas" panose="020B0609020204030204" pitchFamily="49" charset="0"/>
+              </a:rPr>
+              <a:t>document.getElementById</a:t>
+            </a:r>
+            <a:r>
+              <a:rPr lang="en-GB" sz="1800" b="1" dirty="0">
+                <a:solidFill>
+                  <a:srgbClr val="000000"/>
+                </a:solidFill>
+                <a:latin typeface="Consolas" panose="020B0609020204030204" pitchFamily="49" charset="0"/>
+              </a:rPr>
+              <a:t>(</a:t>
+            </a:r>
+            <a:r>
+              <a:rPr lang="en-GB" sz="1800" b="1" dirty="0">
+                <a:solidFill>
+                  <a:srgbClr val="A31515"/>
+                </a:solidFill>
+                <a:latin typeface="Consolas" panose="020B0609020204030204" pitchFamily="49" charset="0"/>
+              </a:rPr>
+              <a:t>"hello"</a:t>
+            </a:r>
+            <a:r>
+              <a:rPr lang="en-GB" sz="1800" b="1" dirty="0">
+                <a:solidFill>
+                  <a:srgbClr val="000000"/>
+                </a:solidFill>
+                <a:latin typeface="Consolas" panose="020B0609020204030204" pitchFamily="49" charset="0"/>
+              </a:rPr>
+              <a:t>);</a:t>
+            </a:r>
+          </a:p>
+          <a:p>
+            <a:r>
+              <a:rPr lang="en-GB" b="1" dirty="0">
+                <a:solidFill>
+                  <a:srgbClr val="000000"/>
+                </a:solidFill>
+                <a:latin typeface="Consolas" panose="020B0609020204030204" pitchFamily="49" charset="0"/>
+              </a:rPr>
+              <a:t>    </a:t>
+            </a:r>
+            <a:r>
+              <a:rPr lang="en-GB" sz="1800" b="1" dirty="0">
+                <a:solidFill>
+                  <a:srgbClr val="000000"/>
+                </a:solidFill>
+                <a:latin typeface="Consolas" panose="020B0609020204030204" pitchFamily="49" charset="0"/>
+              </a:rPr>
+              <a:t>div1.classList.add(</a:t>
+            </a:r>
+            <a:r>
+              <a:rPr lang="en-GB" sz="1800" b="1" dirty="0">
+                <a:solidFill>
+                  <a:srgbClr val="A31515"/>
+                </a:solidFill>
+                <a:latin typeface="Consolas" panose="020B0609020204030204" pitchFamily="49" charset="0"/>
+              </a:rPr>
+              <a:t>"hello")</a:t>
+            </a:r>
+            <a:r>
+              <a:rPr lang="en-GB" sz="1800" b="1" dirty="0">
+                <a:solidFill>
+                  <a:srgbClr val="000000"/>
+                </a:solidFill>
+                <a:latin typeface="Consolas" panose="020B0609020204030204" pitchFamily="49" charset="0"/>
+              </a:rPr>
+              <a:t>;</a:t>
+            </a:r>
+          </a:p>
+          <a:p>
+            <a:r>
+              <a:rPr lang="en-GB" b="1" dirty="0">
+                <a:solidFill>
+                  <a:srgbClr val="000000"/>
+                </a:solidFill>
+                <a:latin typeface="Consolas" panose="020B0609020204030204" pitchFamily="49" charset="0"/>
+              </a:rPr>
+              <a:t>    </a:t>
+            </a:r>
+            <a:r>
+              <a:rPr lang="en-GB" sz="1800" b="1" dirty="0">
+                <a:solidFill>
+                  <a:srgbClr val="000000"/>
+                </a:solidFill>
+                <a:latin typeface="Consolas" panose="020B0609020204030204" pitchFamily="49" charset="0"/>
+              </a:rPr>
+              <a:t>div1.classList.add(</a:t>
+            </a:r>
+            <a:r>
+              <a:rPr lang="en-GB" sz="1800" b="1" dirty="0">
+                <a:solidFill>
+                  <a:srgbClr val="A31515"/>
+                </a:solidFill>
+                <a:latin typeface="Consolas" panose="020B0609020204030204" pitchFamily="49" charset="0"/>
+              </a:rPr>
+              <a:t>"note")</a:t>
+            </a:r>
+            <a:r>
+              <a:rPr lang="en-GB" sz="1800" b="1" dirty="0">
+                <a:solidFill>
+                  <a:srgbClr val="000000"/>
+                </a:solidFill>
+                <a:latin typeface="Consolas" panose="020B0609020204030204" pitchFamily="49" charset="0"/>
+              </a:rPr>
+              <a:t>;</a:t>
+            </a:r>
+          </a:p>
+          <a:p>
+            <a:r>
+              <a:rPr lang="en-GB" sz="1800" b="1" dirty="0">
+                <a:solidFill>
+                  <a:srgbClr val="0000FF"/>
+                </a:solidFill>
+                <a:latin typeface="Consolas" panose="020B0609020204030204" pitchFamily="49" charset="0"/>
+              </a:rPr>
+              <a:t>&lt;/</a:t>
+            </a:r>
+            <a:r>
+              <a:rPr lang="en-GB" sz="1800" b="1" dirty="0">
+                <a:solidFill>
+                  <a:srgbClr val="800000"/>
+                </a:solidFill>
+                <a:latin typeface="Consolas" panose="020B0609020204030204" pitchFamily="49" charset="0"/>
+              </a:rPr>
+              <a:t>script</a:t>
+            </a:r>
+            <a:r>
+              <a:rPr lang="en-GB" sz="1800" b="1" dirty="0">
+                <a:solidFill>
+                  <a:srgbClr val="0000FF"/>
+                </a:solidFill>
+                <a:latin typeface="Consolas" panose="020B0609020204030204" pitchFamily="49" charset="0"/>
+              </a:rPr>
+              <a:t>&gt;</a:t>
+            </a:r>
+            <a:endParaRPr lang="en-GB" sz="1800" b="1" dirty="0">
+              <a:solidFill>
+                <a:srgbClr val="000000"/>
+              </a:solidFill>
+              <a:latin typeface="Consolas" panose="020B0609020204030204" pitchFamily="49" charset="0"/>
+            </a:endParaRPr>
+          </a:p>
+        </p:txBody>
+      </p:sp>
+      <p:sp>
+        <p:nvSpPr>
+          <p:cNvPr id="3" name="TextBox 2">
+            <a:extLst>
+              <a:ext uri="{FF2B5EF4-FFF2-40B4-BE49-F238E27FC236}">
+                <a16:creationId xmlns:a16="http://schemas.microsoft.com/office/drawing/2014/main" id="{08F27F98-9930-69AF-5242-87E30D55BEB1}"/>
+              </a:ext>
+            </a:extLst>
+          </p:cNvPr>
+          <p:cNvSpPr txBox="1"/>
+          <p:nvPr/>
+        </p:nvSpPr>
+        <p:spPr>
+          <a:xfrm>
+            <a:off x="7960900" y="1517054"/>
+            <a:ext cx="3997000" cy="2092881"/>
+          </a:xfrm>
+          <a:prstGeom prst="rect">
+            <a:avLst/>
+          </a:prstGeom>
+          <a:solidFill>
+            <a:schemeClr val="tx1">
+              <a:lumMod val="10000"/>
+              <a:lumOff val="90000"/>
+            </a:schemeClr>
+          </a:solidFill>
+          <a:ln>
+            <a:solidFill>
+              <a:schemeClr val="tx1"/>
+            </a:solidFill>
+          </a:ln>
+          <a:effectLst>
+            <a:outerShdw blurRad="50800" dist="38100" dir="2700000" algn="tl" rotWithShape="0">
+              <a:prstClr val="black">
+                <a:alpha val="40000"/>
+              </a:prstClr>
+            </a:outerShdw>
+          </a:effectLst>
+        </p:spPr>
+        <p:style>
+          <a:lnRef idx="2">
+            <a:schemeClr val="dk1"/>
+          </a:lnRef>
+          <a:fillRef idx="1">
+            <a:schemeClr val="lt1"/>
+          </a:fillRef>
+          <a:effectRef idx="0">
+            <a:schemeClr val="dk1"/>
+          </a:effectRef>
+          <a:fontRef idx="minor">
+            <a:schemeClr val="dk1"/>
+          </a:fontRef>
+        </p:style>
+        <p:txBody>
+          <a:bodyPr wrap="square">
+            <a:spAutoFit/>
+          </a:bodyPr>
+          <a:lstStyle/>
+          <a:p>
+            <a:r>
+              <a:rPr lang="en-GB" sz="1600" b="1" dirty="0">
+                <a:solidFill>
+                  <a:srgbClr val="0000FF"/>
+                </a:solidFill>
+                <a:latin typeface="Consolas" panose="020B0609020204030204" pitchFamily="49" charset="0"/>
+              </a:rPr>
+              <a:t>&lt;</a:t>
+            </a:r>
+            <a:r>
+              <a:rPr lang="en-GB" sz="1600" b="1" dirty="0">
+                <a:solidFill>
+                  <a:srgbClr val="800000"/>
+                </a:solidFill>
+                <a:latin typeface="Consolas" panose="020B0609020204030204" pitchFamily="49" charset="0"/>
+              </a:rPr>
+              <a:t>style</a:t>
+            </a:r>
+            <a:r>
+              <a:rPr lang="en-GB" sz="1600" b="1" dirty="0">
+                <a:solidFill>
+                  <a:srgbClr val="0000FF"/>
+                </a:solidFill>
+                <a:latin typeface="Consolas" panose="020B0609020204030204" pitchFamily="49" charset="0"/>
+              </a:rPr>
+              <a:t>&gt;</a:t>
+            </a:r>
+            <a:endParaRPr lang="en-GB" sz="1600" b="1" dirty="0">
+              <a:solidFill>
+                <a:srgbClr val="000000"/>
+              </a:solidFill>
+              <a:latin typeface="Consolas" panose="020B0609020204030204" pitchFamily="49" charset="0"/>
+            </a:endParaRPr>
+          </a:p>
+          <a:p>
+            <a:r>
+              <a:rPr lang="en-GB" sz="1600" b="1" dirty="0">
+                <a:solidFill>
+                  <a:srgbClr val="000000"/>
+                </a:solidFill>
+                <a:latin typeface="Consolas" panose="020B0609020204030204" pitchFamily="49" charset="0"/>
+              </a:rPr>
+              <a:t> </a:t>
+            </a:r>
+            <a:r>
+              <a:rPr lang="en-GB" sz="1600" b="1" dirty="0">
+                <a:solidFill>
+                  <a:srgbClr val="800000"/>
+                </a:solidFill>
+                <a:latin typeface="Consolas" panose="020B0609020204030204" pitchFamily="49" charset="0"/>
+              </a:rPr>
+              <a:t>.hello</a:t>
+            </a:r>
+            <a:r>
+              <a:rPr lang="en-GB" sz="1600" b="1" dirty="0">
+                <a:solidFill>
+                  <a:srgbClr val="000000"/>
+                </a:solidFill>
+                <a:latin typeface="Consolas" panose="020B0609020204030204" pitchFamily="49" charset="0"/>
+              </a:rPr>
+              <a:t> {</a:t>
+            </a:r>
+          </a:p>
+          <a:p>
+            <a:r>
+              <a:rPr lang="en-GB" sz="1600" b="1" dirty="0">
+                <a:solidFill>
+                  <a:srgbClr val="000000"/>
+                </a:solidFill>
+                <a:latin typeface="Consolas" panose="020B0609020204030204" pitchFamily="49" charset="0"/>
+              </a:rPr>
+              <a:t>        </a:t>
+            </a:r>
+            <a:r>
+              <a:rPr lang="en-GB" sz="1600" b="1" dirty="0">
+                <a:solidFill>
+                  <a:srgbClr val="FF0000"/>
+                </a:solidFill>
+                <a:latin typeface="Consolas" panose="020B0609020204030204" pitchFamily="49" charset="0"/>
+              </a:rPr>
+              <a:t>border</a:t>
+            </a:r>
+            <a:r>
+              <a:rPr lang="en-GB" sz="1600" b="1" dirty="0">
+                <a:solidFill>
+                  <a:srgbClr val="000000"/>
+                </a:solidFill>
+                <a:latin typeface="Consolas" panose="020B0609020204030204" pitchFamily="49" charset="0"/>
+              </a:rPr>
+              <a:t>: </a:t>
+            </a:r>
+            <a:r>
+              <a:rPr lang="en-GB" sz="1600" b="1" dirty="0">
+                <a:solidFill>
+                  <a:srgbClr val="0000FF"/>
+                </a:solidFill>
+                <a:latin typeface="Consolas" panose="020B0609020204030204" pitchFamily="49" charset="0"/>
+              </a:rPr>
+              <a:t>3px</a:t>
+            </a:r>
+            <a:r>
+              <a:rPr lang="en-GB" sz="1600" b="1" dirty="0">
+                <a:solidFill>
+                  <a:srgbClr val="000000"/>
+                </a:solidFill>
+                <a:latin typeface="Consolas" panose="020B0609020204030204" pitchFamily="49" charset="0"/>
+              </a:rPr>
+              <a:t> </a:t>
+            </a:r>
+            <a:r>
+              <a:rPr lang="en-GB" sz="1600" b="1" dirty="0">
+                <a:solidFill>
+                  <a:srgbClr val="0000FF"/>
+                </a:solidFill>
+                <a:latin typeface="Consolas" panose="020B0609020204030204" pitchFamily="49" charset="0"/>
+              </a:rPr>
+              <a:t>solid</a:t>
+            </a:r>
+            <a:r>
+              <a:rPr lang="en-GB" sz="1600" b="1" dirty="0">
+                <a:solidFill>
+                  <a:srgbClr val="000000"/>
+                </a:solidFill>
+                <a:latin typeface="Consolas" panose="020B0609020204030204" pitchFamily="49" charset="0"/>
+              </a:rPr>
+              <a:t> </a:t>
+            </a:r>
+            <a:r>
+              <a:rPr lang="en-GB" sz="1600" b="1" dirty="0">
+                <a:solidFill>
+                  <a:srgbClr val="0000FF"/>
+                </a:solidFill>
+                <a:latin typeface="Consolas" panose="020B0609020204030204" pitchFamily="49" charset="0"/>
+              </a:rPr>
+              <a:t>red</a:t>
+            </a:r>
+            <a:r>
+              <a:rPr lang="en-GB" sz="1600" b="1" dirty="0">
+                <a:solidFill>
+                  <a:srgbClr val="000000"/>
+                </a:solidFill>
+                <a:latin typeface="Consolas" panose="020B0609020204030204" pitchFamily="49" charset="0"/>
+              </a:rPr>
+              <a:t>;</a:t>
+            </a:r>
+          </a:p>
+          <a:p>
+            <a:r>
+              <a:rPr lang="en-GB" sz="1600" b="1" dirty="0">
+                <a:solidFill>
+                  <a:srgbClr val="000000"/>
+                </a:solidFill>
+                <a:latin typeface="Consolas" panose="020B0609020204030204" pitchFamily="49" charset="0"/>
+              </a:rPr>
+              <a:t>    }</a:t>
+            </a:r>
+          </a:p>
+          <a:p>
+            <a:r>
+              <a:rPr lang="en-GB" sz="1600" b="1" dirty="0">
+                <a:solidFill>
+                  <a:srgbClr val="000000"/>
+                </a:solidFill>
+                <a:latin typeface="Consolas" panose="020B0609020204030204" pitchFamily="49" charset="0"/>
+              </a:rPr>
+              <a:t> </a:t>
+            </a:r>
+            <a:r>
+              <a:rPr lang="en-GB" sz="1600" b="1" dirty="0">
+                <a:solidFill>
+                  <a:srgbClr val="800000"/>
+                </a:solidFill>
+                <a:latin typeface="Consolas" panose="020B0609020204030204" pitchFamily="49" charset="0"/>
+              </a:rPr>
+              <a:t>.note</a:t>
+            </a:r>
+            <a:r>
+              <a:rPr lang="en-GB" sz="1600" b="1" dirty="0">
+                <a:solidFill>
+                  <a:srgbClr val="000000"/>
+                </a:solidFill>
+                <a:latin typeface="Consolas" panose="020B0609020204030204" pitchFamily="49" charset="0"/>
+              </a:rPr>
+              <a:t> {</a:t>
+            </a:r>
+          </a:p>
+          <a:p>
+            <a:r>
+              <a:rPr lang="en-GB" sz="1600" b="1" dirty="0">
+                <a:solidFill>
+                  <a:srgbClr val="000000"/>
+                </a:solidFill>
+                <a:latin typeface="Consolas" panose="020B0609020204030204" pitchFamily="49" charset="0"/>
+              </a:rPr>
+              <a:t>     </a:t>
+            </a:r>
+            <a:r>
+              <a:rPr lang="en-GB" sz="1800" b="1" dirty="0">
+                <a:solidFill>
+                  <a:srgbClr val="FF0000"/>
+                </a:solidFill>
+                <a:latin typeface="Consolas" panose="020B0609020204030204" pitchFamily="49" charset="0"/>
+              </a:rPr>
+              <a:t>background-color</a:t>
+            </a:r>
+            <a:r>
+              <a:rPr lang="en-GB" sz="1800" b="1" dirty="0">
+                <a:solidFill>
+                  <a:srgbClr val="000000"/>
+                </a:solidFill>
+                <a:latin typeface="Consolas" panose="020B0609020204030204" pitchFamily="49" charset="0"/>
+              </a:rPr>
+              <a:t>: </a:t>
+            </a:r>
+            <a:r>
+              <a:rPr lang="en-GB" sz="1800" b="1" dirty="0">
+                <a:solidFill>
+                  <a:srgbClr val="0000FF"/>
+                </a:solidFill>
+                <a:latin typeface="Consolas" panose="020B0609020204030204" pitchFamily="49" charset="0"/>
+              </a:rPr>
+              <a:t>yellow</a:t>
+            </a:r>
+            <a:r>
+              <a:rPr lang="en-GB" sz="1800" b="1" dirty="0">
+                <a:solidFill>
+                  <a:srgbClr val="000000"/>
+                </a:solidFill>
+                <a:latin typeface="Consolas" panose="020B0609020204030204" pitchFamily="49" charset="0"/>
+              </a:rPr>
+              <a:t>;</a:t>
+            </a:r>
+            <a:endParaRPr lang="en-GB" sz="1600" b="1" dirty="0">
+              <a:solidFill>
+                <a:srgbClr val="000000"/>
+              </a:solidFill>
+              <a:latin typeface="Consolas" panose="020B0609020204030204" pitchFamily="49" charset="0"/>
+            </a:endParaRPr>
+          </a:p>
+          <a:p>
+            <a:r>
+              <a:rPr lang="en-GB" sz="1600" b="1" dirty="0">
+                <a:solidFill>
+                  <a:srgbClr val="000000"/>
+                </a:solidFill>
+                <a:latin typeface="Consolas" panose="020B0609020204030204" pitchFamily="49" charset="0"/>
+              </a:rPr>
+              <a:t>    }</a:t>
+            </a:r>
+          </a:p>
+          <a:p>
+            <a:r>
+              <a:rPr lang="en-GB" sz="1600" b="1" dirty="0">
+                <a:solidFill>
+                  <a:srgbClr val="0000FF"/>
+                </a:solidFill>
+                <a:latin typeface="Consolas" panose="020B0609020204030204" pitchFamily="49" charset="0"/>
+              </a:rPr>
+              <a:t>&lt;/</a:t>
+            </a:r>
+            <a:r>
+              <a:rPr lang="en-GB" sz="1600" b="1" dirty="0">
+                <a:solidFill>
+                  <a:srgbClr val="800000"/>
+                </a:solidFill>
+                <a:latin typeface="Consolas" panose="020B0609020204030204" pitchFamily="49" charset="0"/>
+              </a:rPr>
+              <a:t>style</a:t>
+            </a:r>
+            <a:r>
+              <a:rPr lang="en-GB" sz="1600" b="1" dirty="0">
+                <a:solidFill>
+                  <a:srgbClr val="0000FF"/>
+                </a:solidFill>
+                <a:latin typeface="Consolas" panose="020B0609020204030204" pitchFamily="49" charset="0"/>
+              </a:rPr>
+              <a:t>&gt;</a:t>
+            </a:r>
+            <a:endParaRPr lang="en-GB" sz="1600" b="1" dirty="0"/>
+          </a:p>
+        </p:txBody>
+      </p:sp>
+    </p:spTree>
+    <p:extLst>
+      <p:ext uri="{BB962C8B-B14F-4D97-AF65-F5344CB8AC3E}">
+        <p14:creationId xmlns:p14="http://schemas.microsoft.com/office/powerpoint/2010/main" val="325324144"/>
+      </p:ext>
+    </p:extLst>
+  </p:cSld>
+  <p:clrMapOvr>
+    <a:masterClrMapping/>
+  </p:clrMapOvr>
+</p:sld>
+</file>
+
+<file path=ppt/slides/slide11.xml><?xml version="1.0" encoding="utf-8"?>
+<p:sld xmlns:a="http://schemas.openxmlformats.org/drawingml/2006/main" xmlns:r="http://schemas.openxmlformats.org/officeDocument/2006/relationships" xmlns:p="http://schemas.openxmlformats.org/presentationml/2006/main">
+  <p:cSld>
+    <p:spTree>
+      <p:nvGrpSpPr>
+        <p:cNvPr id="1" name=""/>
+        <p:cNvGrpSpPr/>
+        <p:nvPr/>
+      </p:nvGrpSpPr>
+      <p:grpSpPr>
+        <a:xfrm>
+          <a:off x="0" y="0"/>
+          <a:ext cx="0" cy="0"/>
+          <a:chOff x="0" y="0"/>
+          <a:chExt cx="0" cy="0"/>
+        </a:xfrm>
+      </p:grpSpPr>
+      <p:sp>
+        <p:nvSpPr>
           <p:cNvPr id="2" name="Slide Number Placeholder 1">
             <a:extLst>
               <a:ext uri="{FF2B5EF4-FFF2-40B4-BE49-F238E27FC236}">
@@ -26400,7 +27407,7 @@
             <a:fld id="{EF892D59-8F09-EF4B-AD6D-DA609442F868}" type="slidenum">
               <a:rPr lang="en-GB" smtClean="0"/>
               <a:pPr/>
-              <a:t>10</a:t>
+              <a:t>11</a:t>
             </a:fld>
             <a:endParaRPr lang="en-GB" dirty="0"/>
           </a:p>
@@ -27822,7 +28829,7 @@
 </p:sld>
 </file>
 
-<file path=ppt/slides/slide11.xml><?xml version="1.0" encoding="utf-8"?>
+<file path=ppt/slides/slide12.xml><?xml version="1.0" encoding="utf-8"?>
 <p:sld xmlns:a="http://schemas.openxmlformats.org/drawingml/2006/main" xmlns:r="http://schemas.openxmlformats.org/officeDocument/2006/relationships" xmlns:p="http://schemas.openxmlformats.org/presentationml/2006/main" show="0">
   <p:cSld>
     <p:spTree>
@@ -27869,7 +28876,7 @@
             <a:fld id="{EF892D59-8F09-EF4B-AD6D-DA609442F868}" type="slidenum">
               <a:rPr lang="en-GB" smtClean="0"/>
               <a:pPr/>
-              <a:t>11</a:t>
+              <a:t>12</a:t>
             </a:fld>
             <a:endParaRPr lang="en-GB" dirty="0"/>
           </a:p>
@@ -29265,7 +30272,7 @@
 </p:sld>
 </file>
 
-<file path=ppt/slides/slide12.xml><?xml version="1.0" encoding="utf-8"?>
+<file path=ppt/slides/slide13.xml><?xml version="1.0" encoding="utf-8"?>
 <p:sld xmlns:a="http://schemas.openxmlformats.org/drawingml/2006/main" xmlns:r="http://schemas.openxmlformats.org/officeDocument/2006/relationships" xmlns:p="http://schemas.openxmlformats.org/presentationml/2006/main">
   <p:cSld>
     <p:spTree>
@@ -29306,7 +30313,7 @@
             <a:fld id="{EF892D59-8F09-EF4B-AD6D-DA609442F868}" type="slidenum">
               <a:rPr lang="en-GB" smtClean="0"/>
               <a:pPr/>
-              <a:t>12</a:t>
+              <a:t>13</a:t>
             </a:fld>
             <a:endParaRPr lang="en-GB" dirty="0"/>
           </a:p>
@@ -30828,7 +31835,7 @@
 </p:sld>
 </file>
 
-<file path=ppt/slides/slide13.xml><?xml version="1.0" encoding="utf-8"?>
+<file path=ppt/slides/slide14.xml><?xml version="1.0" encoding="utf-8"?>
 <p:sld xmlns:a="http://schemas.openxmlformats.org/drawingml/2006/main" xmlns:r="http://schemas.openxmlformats.org/officeDocument/2006/relationships" xmlns:p="http://schemas.openxmlformats.org/presentationml/2006/main" show="0">
   <p:cSld>
     <p:spTree>
@@ -30875,7 +31882,7 @@
             <a:fld id="{EF892D59-8F09-EF4B-AD6D-DA609442F868}" type="slidenum">
               <a:rPr lang="en-GB" smtClean="0"/>
               <a:pPr/>
-              <a:t>13</a:t>
+              <a:t>14</a:t>
             </a:fld>
             <a:endParaRPr lang="en-GB" dirty="0"/>
           </a:p>
@@ -32370,7 +33377,7 @@
 </p:sld>
 </file>
 
-<file path=ppt/slides/slide14.xml><?xml version="1.0" encoding="utf-8"?>
+<file path=ppt/slides/slide15.xml><?xml version="1.0" encoding="utf-8"?>
 <p:sld xmlns:a="http://schemas.openxmlformats.org/drawingml/2006/main" xmlns:r="http://schemas.openxmlformats.org/officeDocument/2006/relationships" xmlns:p="http://schemas.openxmlformats.org/presentationml/2006/main">
   <p:cSld>
     <p:spTree>
@@ -32461,7 +33468,7 @@
 </p:sld>
 </file>
 
-<file path=ppt/slides/slide15.xml><?xml version="1.0" encoding="utf-8"?>
+<file path=ppt/slides/slide16.xml><?xml version="1.0" encoding="utf-8"?>
 <p:sld xmlns:a="http://schemas.openxmlformats.org/drawingml/2006/main" xmlns:r="http://schemas.openxmlformats.org/officeDocument/2006/relationships" xmlns:p="http://schemas.openxmlformats.org/presentationml/2006/main">
   <p:cSld>
     <p:spTree>
@@ -35850,6 +36857,1768 @@
       </p:grpSpPr>
       <p:sp>
         <p:nvSpPr>
+          <p:cNvPr id="4" name="Title 3">
+            <a:extLst>
+              <a:ext uri="{FF2B5EF4-FFF2-40B4-BE49-F238E27FC236}">
+                <a16:creationId xmlns:a16="http://schemas.microsoft.com/office/drawing/2014/main" id="{B6F948DE-9BA4-4416-B213-36446EDA8F67}"/>
+              </a:ext>
+            </a:extLst>
+          </p:cNvPr>
+          <p:cNvSpPr>
+            <a:spLocks noGrp="1"/>
+          </p:cNvSpPr>
+          <p:nvPr>
+            <p:ph type="title"/>
+          </p:nvPr>
+        </p:nvSpPr>
+        <p:spPr/>
+        <p:txBody>
+          <a:bodyPr/>
+          <a:lstStyle/>
+          <a:p>
+            <a:r>
+              <a:rPr lang="en-GB" dirty="0"/>
+              <a:t>Selection of DOM elements – </a:t>
+            </a:r>
+            <a:r>
+              <a:rPr lang="en-GB" dirty="0" err="1"/>
+              <a:t>querySelector</a:t>
+            </a:r>
+            <a:r>
+              <a:rPr lang="en-GB" dirty="0"/>
+              <a:t> method</a:t>
+            </a:r>
+          </a:p>
+        </p:txBody>
+      </p:sp>
+      <p:sp>
+        <p:nvSpPr>
+          <p:cNvPr id="13" name="TextBox 12">
+            <a:extLst>
+              <a:ext uri="{FF2B5EF4-FFF2-40B4-BE49-F238E27FC236}">
+                <a16:creationId xmlns:a16="http://schemas.microsoft.com/office/drawing/2014/main" id="{C32FDF55-EE2B-4CC3-AEC9-09C42FA4D637}"/>
+              </a:ext>
+            </a:extLst>
+          </p:cNvPr>
+          <p:cNvSpPr txBox="1"/>
+          <p:nvPr/>
+        </p:nvSpPr>
+        <p:spPr>
+          <a:xfrm>
+            <a:off x="334210" y="1334242"/>
+            <a:ext cx="4382169" cy="1946687"/>
+          </a:xfrm>
+          <a:prstGeom prst="rect">
+            <a:avLst/>
+          </a:prstGeom>
+          <a:solidFill>
+            <a:schemeClr val="bg1">
+              <a:lumMod val="95000"/>
+            </a:schemeClr>
+          </a:solidFill>
+          <a:ln>
+            <a:solidFill>
+              <a:schemeClr val="bg1">
+                <a:lumMod val="95000"/>
+              </a:schemeClr>
+            </a:solidFill>
+          </a:ln>
+          <a:effectLst>
+            <a:outerShdw blurRad="50800" dist="38100" algn="l" rotWithShape="0">
+              <a:prstClr val="black">
+                <a:alpha val="40000"/>
+              </a:prstClr>
+            </a:outerShdw>
+          </a:effectLst>
+        </p:spPr>
+        <p:style>
+          <a:lnRef idx="2">
+            <a:schemeClr val="dk1"/>
+          </a:lnRef>
+          <a:fillRef idx="1">
+            <a:schemeClr val="lt1"/>
+          </a:fillRef>
+          <a:effectRef idx="0">
+            <a:schemeClr val="dk1"/>
+          </a:effectRef>
+          <a:fontRef idx="minor">
+            <a:schemeClr val="dk1"/>
+          </a:fontRef>
+        </p:style>
+        <p:txBody>
+          <a:bodyPr wrap="square">
+            <a:spAutoFit/>
+          </a:bodyPr>
+          <a:lstStyle/>
+          <a:p>
+            <a:r>
+              <a:rPr lang="en-GB" sz="1600" b="1" dirty="0">
+                <a:solidFill>
+                  <a:srgbClr val="0000FF"/>
+                </a:solidFill>
+                <a:latin typeface="Consolas" panose="020B0609020204030204" pitchFamily="49" charset="0"/>
+              </a:rPr>
+              <a:t>&lt;</a:t>
+            </a:r>
+            <a:r>
+              <a:rPr lang="en-GB" sz="1600" b="1" dirty="0">
+                <a:solidFill>
+                  <a:srgbClr val="800000"/>
+                </a:solidFill>
+                <a:latin typeface="Consolas" panose="020B0609020204030204" pitchFamily="49" charset="0"/>
+              </a:rPr>
+              <a:t>div</a:t>
+            </a:r>
+            <a:r>
+              <a:rPr lang="en-GB" sz="1600" b="1" dirty="0">
+                <a:solidFill>
+                  <a:srgbClr val="000000"/>
+                </a:solidFill>
+                <a:latin typeface="Consolas" panose="020B0609020204030204" pitchFamily="49" charset="0"/>
+              </a:rPr>
+              <a:t> </a:t>
+            </a:r>
+            <a:r>
+              <a:rPr lang="en-GB" sz="1600" b="1" dirty="0">
+                <a:solidFill>
+                  <a:srgbClr val="FF0000"/>
+                </a:solidFill>
+                <a:latin typeface="Consolas" panose="020B0609020204030204" pitchFamily="49" charset="0"/>
+              </a:rPr>
+              <a:t>id</a:t>
+            </a:r>
+            <a:r>
+              <a:rPr lang="en-GB" sz="1600" b="1" dirty="0">
+                <a:solidFill>
+                  <a:srgbClr val="0000FF"/>
+                </a:solidFill>
+                <a:latin typeface="Consolas" panose="020B0609020204030204" pitchFamily="49" charset="0"/>
+              </a:rPr>
+              <a:t>="</a:t>
+            </a:r>
+            <a:r>
+              <a:rPr lang="en-GB" sz="1600" b="1" dirty="0" err="1">
+                <a:solidFill>
+                  <a:srgbClr val="0000FF"/>
+                </a:solidFill>
+                <a:latin typeface="Consolas" panose="020B0609020204030204" pitchFamily="49" charset="0"/>
+              </a:rPr>
+              <a:t>divInfo</a:t>
+            </a:r>
+            <a:r>
+              <a:rPr lang="en-GB" sz="1600" b="1" dirty="0">
+                <a:solidFill>
+                  <a:srgbClr val="0000FF"/>
+                </a:solidFill>
+                <a:latin typeface="Consolas" panose="020B0609020204030204" pitchFamily="49" charset="0"/>
+              </a:rPr>
+              <a:t>"&gt;</a:t>
+            </a:r>
+            <a:r>
+              <a:rPr lang="en-GB" sz="1600" b="1" dirty="0">
+                <a:solidFill>
+                  <a:srgbClr val="000000"/>
+                </a:solidFill>
+                <a:latin typeface="Consolas" panose="020B0609020204030204" pitchFamily="49" charset="0"/>
+              </a:rPr>
+              <a:t>.....</a:t>
+            </a:r>
+            <a:r>
+              <a:rPr lang="en-GB" sz="1600" b="1" dirty="0">
+                <a:solidFill>
+                  <a:srgbClr val="0000FF"/>
+                </a:solidFill>
+                <a:latin typeface="Consolas" panose="020B0609020204030204" pitchFamily="49" charset="0"/>
+              </a:rPr>
+              <a:t>&lt;/</a:t>
+            </a:r>
+            <a:r>
+              <a:rPr lang="en-GB" sz="1600" b="1" dirty="0">
+                <a:solidFill>
+                  <a:srgbClr val="800000"/>
+                </a:solidFill>
+                <a:latin typeface="Consolas" panose="020B0609020204030204" pitchFamily="49" charset="0"/>
+              </a:rPr>
+              <a:t>div</a:t>
+            </a:r>
+            <a:r>
+              <a:rPr lang="en-GB" sz="1600" b="1" dirty="0">
+                <a:solidFill>
+                  <a:srgbClr val="0000FF"/>
+                </a:solidFill>
+                <a:latin typeface="Consolas" panose="020B0609020204030204" pitchFamily="49" charset="0"/>
+              </a:rPr>
+              <a:t>&gt;</a:t>
+            </a:r>
+            <a:endParaRPr lang="en-GB" sz="1600" b="1" dirty="0">
+              <a:solidFill>
+                <a:srgbClr val="000000"/>
+              </a:solidFill>
+              <a:latin typeface="Consolas" panose="020B0609020204030204" pitchFamily="49" charset="0"/>
+            </a:endParaRPr>
+          </a:p>
+          <a:p>
+            <a:r>
+              <a:rPr lang="en-GB" sz="1000" b="1" dirty="0">
+                <a:solidFill>
+                  <a:srgbClr val="000000"/>
+                </a:solidFill>
+                <a:latin typeface="Consolas" panose="020B0609020204030204" pitchFamily="49" charset="0"/>
+              </a:rPr>
+              <a:t>    </a:t>
+            </a:r>
+          </a:p>
+          <a:p>
+            <a:r>
+              <a:rPr lang="en-GB" sz="1600" b="1" dirty="0">
+                <a:solidFill>
+                  <a:srgbClr val="0000FF"/>
+                </a:solidFill>
+                <a:latin typeface="Consolas" panose="020B0609020204030204" pitchFamily="49" charset="0"/>
+              </a:rPr>
+              <a:t>&lt;</a:t>
+            </a:r>
+            <a:r>
+              <a:rPr lang="en-GB" sz="1600" b="1" dirty="0">
+                <a:solidFill>
+                  <a:srgbClr val="800000"/>
+                </a:solidFill>
+                <a:latin typeface="Consolas" panose="020B0609020204030204" pitchFamily="49" charset="0"/>
+              </a:rPr>
+              <a:t>input</a:t>
+            </a:r>
+            <a:r>
+              <a:rPr lang="en-GB" sz="1600" b="1" dirty="0">
+                <a:solidFill>
+                  <a:srgbClr val="000000"/>
+                </a:solidFill>
+                <a:latin typeface="Consolas" panose="020B0609020204030204" pitchFamily="49" charset="0"/>
+              </a:rPr>
+              <a:t> </a:t>
+            </a:r>
+            <a:r>
+              <a:rPr lang="en-GB" sz="1600" b="1" dirty="0">
+                <a:solidFill>
+                  <a:srgbClr val="FF0000"/>
+                </a:solidFill>
+                <a:latin typeface="Consolas" panose="020B0609020204030204" pitchFamily="49" charset="0"/>
+              </a:rPr>
+              <a:t>type</a:t>
+            </a:r>
+            <a:r>
+              <a:rPr lang="en-GB" sz="1600" b="1" dirty="0">
+                <a:solidFill>
+                  <a:srgbClr val="0000FF"/>
+                </a:solidFill>
+                <a:latin typeface="Consolas" panose="020B0609020204030204" pitchFamily="49" charset="0"/>
+              </a:rPr>
+              <a:t>="radio"</a:t>
+            </a:r>
+            <a:r>
+              <a:rPr lang="en-GB" sz="1600" b="1" dirty="0">
+                <a:solidFill>
+                  <a:srgbClr val="000000"/>
+                </a:solidFill>
+                <a:latin typeface="Consolas" panose="020B0609020204030204" pitchFamily="49" charset="0"/>
+              </a:rPr>
+              <a:t> </a:t>
+            </a:r>
+            <a:r>
+              <a:rPr lang="en-GB" sz="1600" b="1" dirty="0">
+                <a:solidFill>
+                  <a:srgbClr val="FF0000"/>
+                </a:solidFill>
+                <a:latin typeface="Consolas" panose="020B0609020204030204" pitchFamily="49" charset="0"/>
+              </a:rPr>
+              <a:t>name</a:t>
+            </a:r>
+            <a:r>
+              <a:rPr lang="en-GB" sz="1600" b="1" dirty="0">
+                <a:solidFill>
+                  <a:srgbClr val="0000FF"/>
+                </a:solidFill>
+                <a:latin typeface="Consolas" panose="020B0609020204030204" pitchFamily="49" charset="0"/>
+              </a:rPr>
+              <a:t>="drink"</a:t>
+            </a:r>
+            <a:r>
+              <a:rPr lang="en-GB" sz="1600" b="1" dirty="0">
+                <a:solidFill>
+                  <a:srgbClr val="000000"/>
+                </a:solidFill>
+                <a:latin typeface="Consolas" panose="020B0609020204030204" pitchFamily="49" charset="0"/>
+              </a:rPr>
+              <a:t> </a:t>
+            </a:r>
+            <a:r>
+              <a:rPr lang="en-GB" sz="1600" b="1" dirty="0">
+                <a:solidFill>
+                  <a:srgbClr val="0000FF"/>
+                </a:solidFill>
+                <a:latin typeface="Consolas" panose="020B0609020204030204" pitchFamily="49" charset="0"/>
+              </a:rPr>
+              <a:t>/&gt;</a:t>
+            </a:r>
+            <a:endParaRPr lang="en-GB" sz="1600" b="1" dirty="0">
+              <a:solidFill>
+                <a:srgbClr val="000000"/>
+              </a:solidFill>
+              <a:latin typeface="Consolas" panose="020B0609020204030204" pitchFamily="49" charset="0"/>
+            </a:endParaRPr>
+          </a:p>
+          <a:p>
+            <a:r>
+              <a:rPr lang="en-GB" sz="1600" b="1" dirty="0">
+                <a:solidFill>
+                  <a:srgbClr val="0000FF"/>
+                </a:solidFill>
+                <a:latin typeface="Consolas" panose="020B0609020204030204" pitchFamily="49" charset="0"/>
+              </a:rPr>
+              <a:t>&lt;</a:t>
+            </a:r>
+            <a:r>
+              <a:rPr lang="en-GB" sz="1600" b="1" dirty="0">
+                <a:solidFill>
+                  <a:srgbClr val="800000"/>
+                </a:solidFill>
+                <a:latin typeface="Consolas" panose="020B0609020204030204" pitchFamily="49" charset="0"/>
+              </a:rPr>
+              <a:t>input</a:t>
+            </a:r>
+            <a:r>
+              <a:rPr lang="en-GB" sz="1600" b="1" dirty="0">
+                <a:solidFill>
+                  <a:srgbClr val="000000"/>
+                </a:solidFill>
+                <a:latin typeface="Consolas" panose="020B0609020204030204" pitchFamily="49" charset="0"/>
+              </a:rPr>
+              <a:t> </a:t>
+            </a:r>
+            <a:r>
+              <a:rPr lang="en-GB" sz="1600" b="1" dirty="0">
+                <a:solidFill>
+                  <a:srgbClr val="FF0000"/>
+                </a:solidFill>
+                <a:latin typeface="Consolas" panose="020B0609020204030204" pitchFamily="49" charset="0"/>
+              </a:rPr>
+              <a:t>type</a:t>
+            </a:r>
+            <a:r>
+              <a:rPr lang="en-GB" sz="1600" b="1" dirty="0">
+                <a:solidFill>
+                  <a:srgbClr val="0000FF"/>
+                </a:solidFill>
+                <a:latin typeface="Consolas" panose="020B0609020204030204" pitchFamily="49" charset="0"/>
+              </a:rPr>
+              <a:t>="radio"</a:t>
+            </a:r>
+            <a:r>
+              <a:rPr lang="en-GB" sz="1600" b="1" dirty="0">
+                <a:solidFill>
+                  <a:srgbClr val="000000"/>
+                </a:solidFill>
+                <a:latin typeface="Consolas" panose="020B0609020204030204" pitchFamily="49" charset="0"/>
+              </a:rPr>
+              <a:t> </a:t>
+            </a:r>
+            <a:r>
+              <a:rPr lang="en-GB" sz="1600" b="1" dirty="0">
+                <a:solidFill>
+                  <a:srgbClr val="FF0000"/>
+                </a:solidFill>
+                <a:latin typeface="Consolas" panose="020B0609020204030204" pitchFamily="49" charset="0"/>
+              </a:rPr>
+              <a:t>name</a:t>
+            </a:r>
+            <a:r>
+              <a:rPr lang="en-GB" sz="1600" b="1" dirty="0">
+                <a:solidFill>
+                  <a:srgbClr val="0000FF"/>
+                </a:solidFill>
+                <a:latin typeface="Consolas" panose="020B0609020204030204" pitchFamily="49" charset="0"/>
+              </a:rPr>
+              <a:t>="drink"</a:t>
+            </a:r>
+            <a:r>
+              <a:rPr lang="en-GB" sz="1600" b="1" dirty="0">
+                <a:solidFill>
+                  <a:srgbClr val="000000"/>
+                </a:solidFill>
+                <a:latin typeface="Consolas" panose="020B0609020204030204" pitchFamily="49" charset="0"/>
+              </a:rPr>
+              <a:t> </a:t>
+            </a:r>
+            <a:r>
+              <a:rPr lang="en-GB" sz="1600" b="1" dirty="0">
+                <a:solidFill>
+                  <a:srgbClr val="0000FF"/>
+                </a:solidFill>
+                <a:latin typeface="Consolas" panose="020B0609020204030204" pitchFamily="49" charset="0"/>
+              </a:rPr>
+              <a:t>/&gt;</a:t>
+            </a:r>
+            <a:endParaRPr lang="en-GB" sz="1600" b="1" dirty="0">
+              <a:solidFill>
+                <a:srgbClr val="000000"/>
+              </a:solidFill>
+              <a:latin typeface="Consolas" panose="020B0609020204030204" pitchFamily="49" charset="0"/>
+            </a:endParaRPr>
+          </a:p>
+          <a:p>
+            <a:r>
+              <a:rPr lang="en-GB" sz="1600" b="1" dirty="0">
+                <a:solidFill>
+                  <a:srgbClr val="0000FF"/>
+                </a:solidFill>
+                <a:latin typeface="Consolas" panose="020B0609020204030204" pitchFamily="49" charset="0"/>
+              </a:rPr>
+              <a:t>&lt;</a:t>
+            </a:r>
+            <a:r>
+              <a:rPr lang="en-GB" sz="1600" b="1" dirty="0">
+                <a:solidFill>
+                  <a:srgbClr val="800000"/>
+                </a:solidFill>
+                <a:latin typeface="Consolas" panose="020B0609020204030204" pitchFamily="49" charset="0"/>
+              </a:rPr>
+              <a:t>input</a:t>
+            </a:r>
+            <a:r>
+              <a:rPr lang="en-GB" sz="1600" b="1" dirty="0">
+                <a:solidFill>
+                  <a:srgbClr val="000000"/>
+                </a:solidFill>
+                <a:latin typeface="Consolas" panose="020B0609020204030204" pitchFamily="49" charset="0"/>
+              </a:rPr>
+              <a:t> </a:t>
+            </a:r>
+            <a:r>
+              <a:rPr lang="en-GB" sz="1600" b="1" dirty="0">
+                <a:solidFill>
+                  <a:srgbClr val="FF0000"/>
+                </a:solidFill>
+                <a:latin typeface="Consolas" panose="020B0609020204030204" pitchFamily="49" charset="0"/>
+              </a:rPr>
+              <a:t>type</a:t>
+            </a:r>
+            <a:r>
+              <a:rPr lang="en-GB" sz="1600" b="1" dirty="0">
+                <a:solidFill>
+                  <a:srgbClr val="0000FF"/>
+                </a:solidFill>
+                <a:latin typeface="Consolas" panose="020B0609020204030204" pitchFamily="49" charset="0"/>
+              </a:rPr>
+              <a:t>="radio"</a:t>
+            </a:r>
+            <a:r>
+              <a:rPr lang="en-GB" sz="1600" b="1" dirty="0">
+                <a:solidFill>
+                  <a:srgbClr val="000000"/>
+                </a:solidFill>
+                <a:latin typeface="Consolas" panose="020B0609020204030204" pitchFamily="49" charset="0"/>
+              </a:rPr>
+              <a:t> </a:t>
+            </a:r>
+            <a:r>
+              <a:rPr lang="en-GB" sz="1600" b="1" dirty="0">
+                <a:solidFill>
+                  <a:srgbClr val="FF0000"/>
+                </a:solidFill>
+                <a:latin typeface="Consolas" panose="020B0609020204030204" pitchFamily="49" charset="0"/>
+              </a:rPr>
+              <a:t>name</a:t>
+            </a:r>
+            <a:r>
+              <a:rPr lang="en-GB" sz="1600" b="1" dirty="0">
+                <a:solidFill>
+                  <a:srgbClr val="0000FF"/>
+                </a:solidFill>
+                <a:latin typeface="Consolas" panose="020B0609020204030204" pitchFamily="49" charset="0"/>
+              </a:rPr>
+              <a:t>="drink"</a:t>
+            </a:r>
+            <a:r>
+              <a:rPr lang="en-GB" sz="1600" b="1" dirty="0">
+                <a:solidFill>
+                  <a:srgbClr val="000000"/>
+                </a:solidFill>
+                <a:latin typeface="Consolas" panose="020B0609020204030204" pitchFamily="49" charset="0"/>
+              </a:rPr>
+              <a:t> </a:t>
+            </a:r>
+            <a:r>
+              <a:rPr lang="en-GB" sz="1600" b="1" dirty="0">
+                <a:solidFill>
+                  <a:srgbClr val="0000FF"/>
+                </a:solidFill>
+                <a:latin typeface="Consolas" panose="020B0609020204030204" pitchFamily="49" charset="0"/>
+              </a:rPr>
+              <a:t>/&gt;</a:t>
+            </a:r>
+            <a:endParaRPr lang="en-GB" sz="1600" b="1" dirty="0">
+              <a:solidFill>
+                <a:srgbClr val="000000"/>
+              </a:solidFill>
+              <a:latin typeface="Consolas" panose="020B0609020204030204" pitchFamily="49" charset="0"/>
+            </a:endParaRPr>
+          </a:p>
+          <a:p>
+            <a:endParaRPr lang="en-GB" sz="1000" b="1" dirty="0">
+              <a:solidFill>
+                <a:srgbClr val="000000"/>
+              </a:solidFill>
+              <a:latin typeface="Consolas" panose="020B0609020204030204" pitchFamily="49" charset="0"/>
+            </a:endParaRPr>
+          </a:p>
+          <a:p>
+            <a:r>
+              <a:rPr lang="en-GB" sz="1600" b="1" dirty="0">
+                <a:solidFill>
+                  <a:srgbClr val="0000FF"/>
+                </a:solidFill>
+                <a:latin typeface="Consolas" panose="020B0609020204030204" pitchFamily="49" charset="0"/>
+              </a:rPr>
+              <a:t>&lt;</a:t>
+            </a:r>
+            <a:r>
+              <a:rPr lang="en-GB" sz="1600" b="1" dirty="0">
+                <a:solidFill>
+                  <a:srgbClr val="800000"/>
+                </a:solidFill>
+                <a:latin typeface="Consolas" panose="020B0609020204030204" pitchFamily="49" charset="0"/>
+              </a:rPr>
+              <a:t>div</a:t>
+            </a:r>
+            <a:r>
+              <a:rPr lang="en-GB" sz="1600" b="1" dirty="0">
+                <a:solidFill>
+                  <a:srgbClr val="000000"/>
+                </a:solidFill>
+                <a:latin typeface="Consolas" panose="020B0609020204030204" pitchFamily="49" charset="0"/>
+              </a:rPr>
+              <a:t> </a:t>
+            </a:r>
+            <a:r>
+              <a:rPr lang="en-GB" sz="1600" b="1" dirty="0">
+                <a:solidFill>
+                  <a:srgbClr val="FF0000"/>
+                </a:solidFill>
+                <a:latin typeface="Consolas" panose="020B0609020204030204" pitchFamily="49" charset="0"/>
+              </a:rPr>
+              <a:t>class</a:t>
+            </a:r>
+            <a:r>
+              <a:rPr lang="en-GB" sz="1600" b="1" dirty="0">
+                <a:solidFill>
+                  <a:srgbClr val="0000FF"/>
+                </a:solidFill>
+                <a:latin typeface="Consolas" panose="020B0609020204030204" pitchFamily="49" charset="0"/>
+              </a:rPr>
+              <a:t>="</a:t>
+            </a:r>
+            <a:r>
+              <a:rPr lang="en-GB" sz="1600" b="1" dirty="0" err="1">
+                <a:solidFill>
+                  <a:srgbClr val="0000FF"/>
+                </a:solidFill>
+                <a:latin typeface="Consolas" panose="020B0609020204030204" pitchFamily="49" charset="0"/>
+              </a:rPr>
+              <a:t>redBorder</a:t>
+            </a:r>
+            <a:r>
+              <a:rPr lang="en-GB" sz="1600" b="1" dirty="0">
+                <a:solidFill>
+                  <a:srgbClr val="0000FF"/>
+                </a:solidFill>
+                <a:latin typeface="Consolas" panose="020B0609020204030204" pitchFamily="49" charset="0"/>
+              </a:rPr>
+              <a:t>"&gt;</a:t>
+            </a:r>
+            <a:r>
+              <a:rPr lang="en-GB" sz="1600" b="1" dirty="0">
+                <a:solidFill>
+                  <a:srgbClr val="000000"/>
+                </a:solidFill>
+                <a:latin typeface="Consolas" panose="020B0609020204030204" pitchFamily="49" charset="0"/>
+              </a:rPr>
+              <a:t>.....</a:t>
+            </a:r>
+            <a:r>
+              <a:rPr lang="en-GB" sz="1600" b="1" dirty="0">
+                <a:solidFill>
+                  <a:srgbClr val="0000FF"/>
+                </a:solidFill>
+                <a:latin typeface="Consolas" panose="020B0609020204030204" pitchFamily="49" charset="0"/>
+              </a:rPr>
+              <a:t>&lt;/</a:t>
+            </a:r>
+            <a:r>
+              <a:rPr lang="en-GB" sz="1600" b="1" dirty="0">
+                <a:solidFill>
+                  <a:srgbClr val="800000"/>
+                </a:solidFill>
+                <a:latin typeface="Consolas" panose="020B0609020204030204" pitchFamily="49" charset="0"/>
+              </a:rPr>
+              <a:t>div</a:t>
+            </a:r>
+            <a:r>
+              <a:rPr lang="en-GB" sz="1600" b="1" dirty="0">
+                <a:solidFill>
+                  <a:srgbClr val="0000FF"/>
+                </a:solidFill>
+                <a:latin typeface="Consolas" panose="020B0609020204030204" pitchFamily="49" charset="0"/>
+              </a:rPr>
+              <a:t>&gt;</a:t>
+            </a:r>
+            <a:endParaRPr lang="en-GB" sz="1600" b="1" dirty="0">
+              <a:solidFill>
+                <a:srgbClr val="000000"/>
+              </a:solidFill>
+              <a:latin typeface="Consolas" panose="020B0609020204030204" pitchFamily="49" charset="0"/>
+            </a:endParaRPr>
+          </a:p>
+          <a:p>
+            <a:r>
+              <a:rPr lang="en-GB" sz="1600" b="1" dirty="0">
+                <a:solidFill>
+                  <a:srgbClr val="0000FF"/>
+                </a:solidFill>
+                <a:latin typeface="Consolas" panose="020B0609020204030204" pitchFamily="49" charset="0"/>
+              </a:rPr>
+              <a:t>&lt;</a:t>
+            </a:r>
+            <a:r>
+              <a:rPr lang="en-GB" sz="1600" b="1" dirty="0">
+                <a:solidFill>
+                  <a:srgbClr val="800000"/>
+                </a:solidFill>
+                <a:latin typeface="Consolas" panose="020B0609020204030204" pitchFamily="49" charset="0"/>
+              </a:rPr>
+              <a:t>div</a:t>
+            </a:r>
+            <a:r>
+              <a:rPr lang="en-GB" sz="1600" b="1" dirty="0">
+                <a:solidFill>
+                  <a:srgbClr val="000000"/>
+                </a:solidFill>
+                <a:latin typeface="Consolas" panose="020B0609020204030204" pitchFamily="49" charset="0"/>
+              </a:rPr>
+              <a:t> </a:t>
+            </a:r>
+            <a:r>
+              <a:rPr lang="en-GB" sz="1600" b="1" dirty="0">
+                <a:solidFill>
+                  <a:srgbClr val="FF0000"/>
+                </a:solidFill>
+                <a:latin typeface="Consolas" panose="020B0609020204030204" pitchFamily="49" charset="0"/>
+              </a:rPr>
+              <a:t>class</a:t>
+            </a:r>
+            <a:r>
+              <a:rPr lang="en-GB" sz="1600" b="1" dirty="0">
+                <a:solidFill>
+                  <a:srgbClr val="0000FF"/>
+                </a:solidFill>
+                <a:latin typeface="Consolas" panose="020B0609020204030204" pitchFamily="49" charset="0"/>
+              </a:rPr>
+              <a:t>="</a:t>
+            </a:r>
+            <a:r>
+              <a:rPr lang="en-GB" sz="1600" b="1" dirty="0" err="1">
+                <a:solidFill>
+                  <a:srgbClr val="0000FF"/>
+                </a:solidFill>
+                <a:latin typeface="Consolas" panose="020B0609020204030204" pitchFamily="49" charset="0"/>
+              </a:rPr>
+              <a:t>redBorder</a:t>
+            </a:r>
+            <a:r>
+              <a:rPr lang="en-GB" sz="1600" b="1" dirty="0">
+                <a:solidFill>
+                  <a:srgbClr val="0000FF"/>
+                </a:solidFill>
+                <a:latin typeface="Consolas" panose="020B0609020204030204" pitchFamily="49" charset="0"/>
+              </a:rPr>
+              <a:t>"&gt;</a:t>
+            </a:r>
+            <a:r>
+              <a:rPr lang="en-GB" sz="1600" b="1" dirty="0">
+                <a:solidFill>
+                  <a:srgbClr val="000000"/>
+                </a:solidFill>
+                <a:latin typeface="Consolas" panose="020B0609020204030204" pitchFamily="49" charset="0"/>
+              </a:rPr>
+              <a:t>.....</a:t>
+            </a:r>
+            <a:r>
+              <a:rPr lang="en-GB" sz="1600" b="1" dirty="0">
+                <a:solidFill>
+                  <a:srgbClr val="0000FF"/>
+                </a:solidFill>
+                <a:latin typeface="Consolas" panose="020B0609020204030204" pitchFamily="49" charset="0"/>
+              </a:rPr>
+              <a:t>&lt;/</a:t>
+            </a:r>
+            <a:r>
+              <a:rPr lang="en-GB" sz="1600" b="1" dirty="0">
+                <a:solidFill>
+                  <a:srgbClr val="800000"/>
+                </a:solidFill>
+                <a:latin typeface="Consolas" panose="020B0609020204030204" pitchFamily="49" charset="0"/>
+              </a:rPr>
+              <a:t>div</a:t>
+            </a:r>
+            <a:r>
+              <a:rPr lang="en-GB" sz="1600" b="1" dirty="0">
+                <a:solidFill>
+                  <a:srgbClr val="0000FF"/>
+                </a:solidFill>
+                <a:latin typeface="Consolas" panose="020B0609020204030204" pitchFamily="49" charset="0"/>
+              </a:rPr>
+              <a:t>&gt;</a:t>
+            </a:r>
+            <a:endParaRPr lang="en-GB" sz="1600" b="1" dirty="0">
+              <a:solidFill>
+                <a:srgbClr val="000000"/>
+              </a:solidFill>
+              <a:latin typeface="Consolas" panose="020B0609020204030204" pitchFamily="49" charset="0"/>
+            </a:endParaRPr>
+          </a:p>
+        </p:txBody>
+      </p:sp>
+      <p:sp>
+        <p:nvSpPr>
+          <p:cNvPr id="15" name="TextBox 14">
+            <a:extLst>
+              <a:ext uri="{FF2B5EF4-FFF2-40B4-BE49-F238E27FC236}">
+                <a16:creationId xmlns:a16="http://schemas.microsoft.com/office/drawing/2014/main" id="{D680B986-CFE9-4237-B810-6C9F4B6631DC}"/>
+              </a:ext>
+            </a:extLst>
+          </p:cNvPr>
+          <p:cNvSpPr txBox="1"/>
+          <p:nvPr/>
+        </p:nvSpPr>
+        <p:spPr>
+          <a:xfrm>
+            <a:off x="321607" y="3520960"/>
+            <a:ext cx="6944431" cy="1160767"/>
+          </a:xfrm>
+          <a:prstGeom prst="rect">
+            <a:avLst/>
+          </a:prstGeom>
+          <a:solidFill>
+            <a:schemeClr val="bg1">
+              <a:lumMod val="95000"/>
+            </a:schemeClr>
+          </a:solidFill>
+          <a:ln>
+            <a:solidFill>
+              <a:schemeClr val="bg1">
+                <a:lumMod val="95000"/>
+              </a:schemeClr>
+            </a:solidFill>
+          </a:ln>
+          <a:effectLst>
+            <a:outerShdw blurRad="50800" dist="38100" algn="l" rotWithShape="0">
+              <a:prstClr val="black">
+                <a:alpha val="40000"/>
+              </a:prstClr>
+            </a:outerShdw>
+          </a:effectLst>
+        </p:spPr>
+        <p:style>
+          <a:lnRef idx="2">
+            <a:schemeClr val="dk1"/>
+          </a:lnRef>
+          <a:fillRef idx="1">
+            <a:schemeClr val="lt1"/>
+          </a:fillRef>
+          <a:effectRef idx="0">
+            <a:schemeClr val="dk1"/>
+          </a:effectRef>
+          <a:fontRef idx="minor">
+            <a:schemeClr val="dk1"/>
+          </a:fontRef>
+        </p:style>
+        <p:txBody>
+          <a:bodyPr wrap="square">
+            <a:spAutoFit/>
+          </a:bodyPr>
+          <a:lstStyle/>
+          <a:p>
+            <a:pPr>
+              <a:lnSpc>
+                <a:spcPct val="150000"/>
+              </a:lnSpc>
+            </a:pPr>
+            <a:r>
+              <a:rPr lang="en-GB" sz="1600" b="1" dirty="0">
+                <a:solidFill>
+                  <a:srgbClr val="0000FF"/>
+                </a:solidFill>
+                <a:latin typeface="Consolas" panose="020B0609020204030204" pitchFamily="49" charset="0"/>
+              </a:rPr>
+              <a:t>let</a:t>
+            </a:r>
+            <a:r>
+              <a:rPr lang="en-GB" sz="1600" b="1" dirty="0">
+                <a:solidFill>
+                  <a:srgbClr val="000000"/>
+                </a:solidFill>
+                <a:latin typeface="Consolas" panose="020B0609020204030204" pitchFamily="49" charset="0"/>
+              </a:rPr>
+              <a:t> info = </a:t>
+            </a:r>
+            <a:r>
+              <a:rPr lang="en-GB" sz="1600" b="1" dirty="0" err="1">
+                <a:solidFill>
+                  <a:srgbClr val="000000"/>
+                </a:solidFill>
+                <a:latin typeface="Consolas" panose="020B0609020204030204" pitchFamily="49" charset="0"/>
+              </a:rPr>
+              <a:t>document.getElementById</a:t>
+            </a:r>
+            <a:r>
+              <a:rPr lang="en-GB" sz="1600" b="1" dirty="0">
+                <a:solidFill>
+                  <a:srgbClr val="000000"/>
+                </a:solidFill>
+                <a:latin typeface="Consolas" panose="020B0609020204030204" pitchFamily="49" charset="0"/>
+              </a:rPr>
+              <a:t>(</a:t>
+            </a:r>
+            <a:r>
+              <a:rPr lang="en-GB" sz="1600" b="1" dirty="0">
+                <a:solidFill>
+                  <a:srgbClr val="A31515"/>
+                </a:solidFill>
+                <a:latin typeface="Consolas" panose="020B0609020204030204" pitchFamily="49" charset="0"/>
+              </a:rPr>
+              <a:t>'</a:t>
+            </a:r>
+            <a:r>
+              <a:rPr lang="en-GB" sz="1600" b="1" dirty="0" err="1">
+                <a:solidFill>
+                  <a:srgbClr val="A31515"/>
+                </a:solidFill>
+                <a:latin typeface="Consolas" panose="020B0609020204030204" pitchFamily="49" charset="0"/>
+              </a:rPr>
+              <a:t>divInfo</a:t>
+            </a:r>
+            <a:r>
+              <a:rPr lang="en-GB" sz="1600" b="1" dirty="0">
+                <a:solidFill>
+                  <a:srgbClr val="A31515"/>
+                </a:solidFill>
+                <a:latin typeface="Consolas" panose="020B0609020204030204" pitchFamily="49" charset="0"/>
+              </a:rPr>
+              <a:t>'</a:t>
+            </a:r>
+            <a:r>
+              <a:rPr lang="en-GB" sz="1600" b="1" dirty="0">
+                <a:solidFill>
+                  <a:srgbClr val="000000"/>
+                </a:solidFill>
+                <a:latin typeface="Consolas" panose="020B0609020204030204" pitchFamily="49" charset="0"/>
+              </a:rPr>
+              <a:t>);</a:t>
+            </a:r>
+          </a:p>
+          <a:p>
+            <a:pPr>
+              <a:lnSpc>
+                <a:spcPct val="150000"/>
+              </a:lnSpc>
+            </a:pPr>
+            <a:r>
+              <a:rPr lang="en-GB" sz="1600" b="1" dirty="0">
+                <a:solidFill>
+                  <a:srgbClr val="0000FF"/>
+                </a:solidFill>
+                <a:latin typeface="Consolas" panose="020B0609020204030204" pitchFamily="49" charset="0"/>
+              </a:rPr>
+              <a:t>let</a:t>
+            </a:r>
+            <a:r>
+              <a:rPr lang="en-GB" sz="1600" b="1" dirty="0">
+                <a:solidFill>
+                  <a:srgbClr val="000000"/>
+                </a:solidFill>
+                <a:latin typeface="Consolas" panose="020B0609020204030204" pitchFamily="49" charset="0"/>
+              </a:rPr>
+              <a:t> drinks = </a:t>
+            </a:r>
+            <a:r>
+              <a:rPr lang="en-GB" sz="1600" b="1" dirty="0" err="1">
+                <a:solidFill>
+                  <a:srgbClr val="000000"/>
+                </a:solidFill>
+                <a:latin typeface="Consolas" panose="020B0609020204030204" pitchFamily="49" charset="0"/>
+              </a:rPr>
+              <a:t>document.getElementsByName</a:t>
+            </a:r>
+            <a:r>
+              <a:rPr lang="en-GB" sz="1600" b="1" dirty="0">
+                <a:solidFill>
+                  <a:srgbClr val="000000"/>
+                </a:solidFill>
+                <a:latin typeface="Consolas" panose="020B0609020204030204" pitchFamily="49" charset="0"/>
+              </a:rPr>
+              <a:t>(</a:t>
+            </a:r>
+            <a:r>
+              <a:rPr lang="en-GB" sz="1600" b="1" dirty="0">
+                <a:solidFill>
+                  <a:srgbClr val="A31515"/>
+                </a:solidFill>
+                <a:latin typeface="Consolas" panose="020B0609020204030204" pitchFamily="49" charset="0"/>
+              </a:rPr>
+              <a:t>'drink'</a:t>
+            </a:r>
+            <a:r>
+              <a:rPr lang="en-GB" sz="1600" b="1" dirty="0">
+                <a:solidFill>
+                  <a:srgbClr val="000000"/>
+                </a:solidFill>
+                <a:latin typeface="Consolas" panose="020B0609020204030204" pitchFamily="49" charset="0"/>
+              </a:rPr>
+              <a:t>);</a:t>
+            </a:r>
+          </a:p>
+          <a:p>
+            <a:pPr>
+              <a:lnSpc>
+                <a:spcPct val="150000"/>
+              </a:lnSpc>
+            </a:pPr>
+            <a:r>
+              <a:rPr lang="en-GB" sz="1600" b="1" dirty="0">
+                <a:solidFill>
+                  <a:srgbClr val="0000FF"/>
+                </a:solidFill>
+                <a:latin typeface="Consolas" panose="020B0609020204030204" pitchFamily="49" charset="0"/>
+              </a:rPr>
+              <a:t>let</a:t>
+            </a:r>
+            <a:r>
+              <a:rPr lang="en-GB" sz="1600" b="1" dirty="0">
+                <a:solidFill>
+                  <a:srgbClr val="000000"/>
+                </a:solidFill>
+                <a:latin typeface="Consolas" panose="020B0609020204030204" pitchFamily="49" charset="0"/>
+              </a:rPr>
+              <a:t> </a:t>
+            </a:r>
+            <a:r>
+              <a:rPr lang="en-GB" sz="1600" b="1" dirty="0" err="1">
+                <a:solidFill>
+                  <a:srgbClr val="000000"/>
+                </a:solidFill>
+                <a:latin typeface="Consolas" panose="020B0609020204030204" pitchFamily="49" charset="0"/>
+              </a:rPr>
+              <a:t>divs</a:t>
+            </a:r>
+            <a:r>
+              <a:rPr lang="en-GB" sz="1600" b="1" dirty="0">
+                <a:solidFill>
+                  <a:srgbClr val="000000"/>
+                </a:solidFill>
+                <a:latin typeface="Consolas" panose="020B0609020204030204" pitchFamily="49" charset="0"/>
+              </a:rPr>
+              <a:t> = </a:t>
+            </a:r>
+            <a:r>
+              <a:rPr lang="en-GB" sz="1600" b="1" dirty="0" err="1">
+                <a:solidFill>
+                  <a:srgbClr val="000000"/>
+                </a:solidFill>
+                <a:latin typeface="Consolas" panose="020B0609020204030204" pitchFamily="49" charset="0"/>
+              </a:rPr>
+              <a:t>document.getElementsByClassName</a:t>
+            </a:r>
+            <a:r>
+              <a:rPr lang="en-GB" sz="1600" b="1" dirty="0">
+                <a:solidFill>
+                  <a:srgbClr val="000000"/>
+                </a:solidFill>
+                <a:latin typeface="Consolas" panose="020B0609020204030204" pitchFamily="49" charset="0"/>
+              </a:rPr>
+              <a:t>(</a:t>
+            </a:r>
+            <a:r>
+              <a:rPr lang="en-GB" sz="1600" b="1" dirty="0">
+                <a:solidFill>
+                  <a:srgbClr val="A31515"/>
+                </a:solidFill>
+                <a:latin typeface="Consolas" panose="020B0609020204030204" pitchFamily="49" charset="0"/>
+              </a:rPr>
+              <a:t>'</a:t>
+            </a:r>
+            <a:r>
+              <a:rPr lang="en-GB" sz="1600" b="1" dirty="0" err="1">
+                <a:solidFill>
+                  <a:srgbClr val="A31515"/>
+                </a:solidFill>
+                <a:latin typeface="Consolas" panose="020B0609020204030204" pitchFamily="49" charset="0"/>
+              </a:rPr>
+              <a:t>redBorder</a:t>
+            </a:r>
+            <a:r>
+              <a:rPr lang="en-GB" sz="1600" b="1" dirty="0">
+                <a:solidFill>
+                  <a:srgbClr val="A31515"/>
+                </a:solidFill>
+                <a:latin typeface="Consolas" panose="020B0609020204030204" pitchFamily="49" charset="0"/>
+              </a:rPr>
+              <a:t>'</a:t>
+            </a:r>
+            <a:r>
+              <a:rPr lang="en-GB" sz="1600" b="1" dirty="0">
+                <a:solidFill>
+                  <a:srgbClr val="000000"/>
+                </a:solidFill>
+                <a:latin typeface="Consolas" panose="020B0609020204030204" pitchFamily="49" charset="0"/>
+              </a:rPr>
+              <a:t>);</a:t>
+            </a:r>
+          </a:p>
+        </p:txBody>
+      </p:sp>
+      <p:sp>
+        <p:nvSpPr>
+          <p:cNvPr id="17" name="TextBox 16">
+            <a:extLst>
+              <a:ext uri="{FF2B5EF4-FFF2-40B4-BE49-F238E27FC236}">
+                <a16:creationId xmlns:a16="http://schemas.microsoft.com/office/drawing/2014/main" id="{97452C11-CDC4-4C97-990F-FF30793F32C1}"/>
+              </a:ext>
+            </a:extLst>
+          </p:cNvPr>
+          <p:cNvSpPr txBox="1"/>
+          <p:nvPr/>
+        </p:nvSpPr>
+        <p:spPr>
+          <a:xfrm>
+            <a:off x="339971" y="4973165"/>
+            <a:ext cx="7200069" cy="1294329"/>
+          </a:xfrm>
+          <a:prstGeom prst="rect">
+            <a:avLst/>
+          </a:prstGeom>
+          <a:solidFill>
+            <a:schemeClr val="bg1">
+              <a:lumMod val="95000"/>
+            </a:schemeClr>
+          </a:solidFill>
+          <a:ln>
+            <a:solidFill>
+              <a:schemeClr val="bg1">
+                <a:lumMod val="95000"/>
+              </a:schemeClr>
+            </a:solidFill>
+          </a:ln>
+          <a:effectLst>
+            <a:outerShdw blurRad="50800" dist="38100" algn="l" rotWithShape="0">
+              <a:prstClr val="black">
+                <a:alpha val="40000"/>
+              </a:prstClr>
+            </a:outerShdw>
+          </a:effectLst>
+        </p:spPr>
+        <p:style>
+          <a:lnRef idx="2">
+            <a:schemeClr val="dk1"/>
+          </a:lnRef>
+          <a:fillRef idx="1">
+            <a:schemeClr val="lt1"/>
+          </a:fillRef>
+          <a:effectRef idx="0">
+            <a:schemeClr val="dk1"/>
+          </a:effectRef>
+          <a:fontRef idx="minor">
+            <a:schemeClr val="dk1"/>
+          </a:fontRef>
+        </p:style>
+        <p:txBody>
+          <a:bodyPr wrap="square">
+            <a:spAutoFit/>
+          </a:bodyPr>
+          <a:lstStyle/>
+          <a:p>
+            <a:pPr>
+              <a:lnSpc>
+                <a:spcPct val="150000"/>
+              </a:lnSpc>
+            </a:pPr>
+            <a:r>
+              <a:rPr lang="en-GB" b="1" dirty="0">
+                <a:solidFill>
+                  <a:srgbClr val="0000FF"/>
+                </a:solidFill>
+                <a:latin typeface="Consolas" panose="020B0609020204030204" pitchFamily="49" charset="0"/>
+              </a:rPr>
+              <a:t>let</a:t>
+            </a:r>
+            <a:r>
+              <a:rPr lang="en-GB" b="1" dirty="0">
+                <a:solidFill>
+                  <a:srgbClr val="000000"/>
+                </a:solidFill>
+                <a:latin typeface="Consolas" panose="020B0609020204030204" pitchFamily="49" charset="0"/>
+              </a:rPr>
+              <a:t> info = </a:t>
+            </a:r>
+            <a:r>
+              <a:rPr lang="en-GB" b="1" dirty="0" err="1">
+                <a:solidFill>
+                  <a:srgbClr val="000000"/>
+                </a:solidFill>
+                <a:latin typeface="Consolas" panose="020B0609020204030204" pitchFamily="49" charset="0"/>
+              </a:rPr>
+              <a:t>document.querySelector</a:t>
+            </a:r>
+            <a:r>
+              <a:rPr lang="en-GB" b="1" dirty="0">
+                <a:solidFill>
+                  <a:srgbClr val="000000"/>
+                </a:solidFill>
+                <a:latin typeface="Consolas" panose="020B0609020204030204" pitchFamily="49" charset="0"/>
+              </a:rPr>
+              <a:t>(</a:t>
+            </a:r>
+            <a:r>
+              <a:rPr lang="en-GB" b="1" dirty="0">
+                <a:solidFill>
+                  <a:srgbClr val="A31515"/>
+                </a:solidFill>
+                <a:latin typeface="Consolas" panose="020B0609020204030204" pitchFamily="49" charset="0"/>
+              </a:rPr>
+              <a:t>'#</a:t>
+            </a:r>
+            <a:r>
+              <a:rPr lang="en-GB" b="1" dirty="0" err="1">
+                <a:solidFill>
+                  <a:srgbClr val="A31515"/>
+                </a:solidFill>
+                <a:latin typeface="Consolas" panose="020B0609020204030204" pitchFamily="49" charset="0"/>
+              </a:rPr>
+              <a:t>divInfo</a:t>
+            </a:r>
+            <a:r>
+              <a:rPr lang="en-GB" b="1" dirty="0">
+                <a:solidFill>
+                  <a:srgbClr val="A31515"/>
+                </a:solidFill>
+                <a:latin typeface="Consolas" panose="020B0609020204030204" pitchFamily="49" charset="0"/>
+              </a:rPr>
+              <a:t>'</a:t>
+            </a:r>
+            <a:r>
+              <a:rPr lang="en-GB" b="1" dirty="0">
+                <a:solidFill>
+                  <a:srgbClr val="000000"/>
+                </a:solidFill>
+                <a:latin typeface="Consolas" panose="020B0609020204030204" pitchFamily="49" charset="0"/>
+              </a:rPr>
+              <a:t>);</a:t>
+            </a:r>
+          </a:p>
+          <a:p>
+            <a:pPr>
+              <a:lnSpc>
+                <a:spcPct val="150000"/>
+              </a:lnSpc>
+            </a:pPr>
+            <a:r>
+              <a:rPr lang="en-GB" b="1" dirty="0">
+                <a:solidFill>
+                  <a:srgbClr val="0000FF"/>
+                </a:solidFill>
+                <a:latin typeface="Consolas" panose="020B0609020204030204" pitchFamily="49" charset="0"/>
+              </a:rPr>
+              <a:t>let</a:t>
+            </a:r>
+            <a:r>
+              <a:rPr lang="en-GB" b="1" dirty="0">
+                <a:solidFill>
+                  <a:srgbClr val="000000"/>
+                </a:solidFill>
+                <a:latin typeface="Consolas" panose="020B0609020204030204" pitchFamily="49" charset="0"/>
+              </a:rPr>
+              <a:t> drinks = </a:t>
+            </a:r>
+            <a:r>
+              <a:rPr lang="en-GB" b="1" dirty="0" err="1">
+                <a:solidFill>
+                  <a:srgbClr val="000000"/>
+                </a:solidFill>
+                <a:latin typeface="Consolas" panose="020B0609020204030204" pitchFamily="49" charset="0"/>
+              </a:rPr>
+              <a:t>document.querySelectorAll</a:t>
+            </a:r>
+            <a:r>
+              <a:rPr lang="en-GB" b="1" dirty="0">
+                <a:solidFill>
+                  <a:srgbClr val="000000"/>
+                </a:solidFill>
+                <a:latin typeface="Consolas" panose="020B0609020204030204" pitchFamily="49" charset="0"/>
+              </a:rPr>
+              <a:t>(</a:t>
+            </a:r>
+            <a:r>
+              <a:rPr lang="en-GB" b="1" dirty="0">
+                <a:solidFill>
+                  <a:srgbClr val="A31515"/>
+                </a:solidFill>
+                <a:latin typeface="Consolas" panose="020B0609020204030204" pitchFamily="49" charset="0"/>
+              </a:rPr>
+              <a:t>'[name=drink]'</a:t>
+            </a:r>
+            <a:r>
+              <a:rPr lang="en-GB" b="1" dirty="0">
+                <a:solidFill>
+                  <a:srgbClr val="000000"/>
+                </a:solidFill>
+                <a:latin typeface="Consolas" panose="020B0609020204030204" pitchFamily="49" charset="0"/>
+              </a:rPr>
+              <a:t>);</a:t>
+            </a:r>
+          </a:p>
+          <a:p>
+            <a:pPr>
+              <a:lnSpc>
+                <a:spcPct val="150000"/>
+              </a:lnSpc>
+            </a:pPr>
+            <a:r>
+              <a:rPr lang="en-GB" b="1" dirty="0">
+                <a:solidFill>
+                  <a:srgbClr val="0000FF"/>
+                </a:solidFill>
+                <a:latin typeface="Consolas" panose="020B0609020204030204" pitchFamily="49" charset="0"/>
+              </a:rPr>
+              <a:t>let</a:t>
+            </a:r>
+            <a:r>
+              <a:rPr lang="en-GB" b="1" dirty="0">
+                <a:solidFill>
+                  <a:srgbClr val="000000"/>
+                </a:solidFill>
+                <a:latin typeface="Consolas" panose="020B0609020204030204" pitchFamily="49" charset="0"/>
+              </a:rPr>
+              <a:t> </a:t>
+            </a:r>
+            <a:r>
+              <a:rPr lang="en-GB" b="1" dirty="0" err="1">
+                <a:solidFill>
+                  <a:srgbClr val="000000"/>
+                </a:solidFill>
+                <a:latin typeface="Consolas" panose="020B0609020204030204" pitchFamily="49" charset="0"/>
+              </a:rPr>
+              <a:t>divs</a:t>
+            </a:r>
+            <a:r>
+              <a:rPr lang="en-GB" b="1" dirty="0">
+                <a:solidFill>
+                  <a:srgbClr val="000000"/>
+                </a:solidFill>
+                <a:latin typeface="Consolas" panose="020B0609020204030204" pitchFamily="49" charset="0"/>
+              </a:rPr>
+              <a:t> = </a:t>
+            </a:r>
+            <a:r>
+              <a:rPr lang="en-GB" b="1" dirty="0" err="1">
+                <a:solidFill>
+                  <a:srgbClr val="000000"/>
+                </a:solidFill>
+                <a:latin typeface="Consolas" panose="020B0609020204030204" pitchFamily="49" charset="0"/>
+              </a:rPr>
+              <a:t>document.querySelectorAll</a:t>
+            </a:r>
+            <a:r>
+              <a:rPr lang="en-GB" b="1" dirty="0">
+                <a:solidFill>
+                  <a:srgbClr val="000000"/>
+                </a:solidFill>
+                <a:latin typeface="Consolas" panose="020B0609020204030204" pitchFamily="49" charset="0"/>
+              </a:rPr>
+              <a:t>(</a:t>
+            </a:r>
+            <a:r>
+              <a:rPr lang="en-GB" b="1" dirty="0">
+                <a:solidFill>
+                  <a:srgbClr val="A31515"/>
+                </a:solidFill>
+                <a:latin typeface="Consolas" panose="020B0609020204030204" pitchFamily="49" charset="0"/>
+              </a:rPr>
+              <a:t>'.</a:t>
+            </a:r>
+            <a:r>
+              <a:rPr lang="en-GB" b="1" dirty="0" err="1">
+                <a:solidFill>
+                  <a:srgbClr val="A31515"/>
+                </a:solidFill>
+                <a:latin typeface="Consolas" panose="020B0609020204030204" pitchFamily="49" charset="0"/>
+              </a:rPr>
+              <a:t>redBorder</a:t>
+            </a:r>
+            <a:r>
+              <a:rPr lang="en-GB" b="1" dirty="0">
+                <a:solidFill>
+                  <a:srgbClr val="A31515"/>
+                </a:solidFill>
+                <a:latin typeface="Consolas" panose="020B0609020204030204" pitchFamily="49" charset="0"/>
+              </a:rPr>
+              <a:t>'</a:t>
+            </a:r>
+            <a:r>
+              <a:rPr lang="en-GB" b="1" dirty="0">
+                <a:solidFill>
+                  <a:srgbClr val="000000"/>
+                </a:solidFill>
+                <a:latin typeface="Consolas" panose="020B0609020204030204" pitchFamily="49" charset="0"/>
+              </a:rPr>
+              <a:t>);</a:t>
+            </a:r>
+          </a:p>
+        </p:txBody>
+      </p:sp>
+      <p:sp>
+        <p:nvSpPr>
+          <p:cNvPr id="19" name="TextBox 18">
+            <a:extLst>
+              <a:ext uri="{FF2B5EF4-FFF2-40B4-BE49-F238E27FC236}">
+                <a16:creationId xmlns:a16="http://schemas.microsoft.com/office/drawing/2014/main" id="{682D595E-439D-48FC-8AA1-59C02279ECD7}"/>
+              </a:ext>
+            </a:extLst>
+          </p:cNvPr>
+          <p:cNvSpPr txBox="1"/>
+          <p:nvPr/>
+        </p:nvSpPr>
+        <p:spPr>
+          <a:xfrm>
+            <a:off x="7979333" y="3520960"/>
+            <a:ext cx="4093206" cy="1294329"/>
+          </a:xfrm>
+          <a:prstGeom prst="rect">
+            <a:avLst/>
+          </a:prstGeom>
+          <a:solidFill>
+            <a:schemeClr val="bg1">
+              <a:lumMod val="95000"/>
+            </a:schemeClr>
+          </a:solidFill>
+          <a:ln>
+            <a:solidFill>
+              <a:schemeClr val="bg1">
+                <a:lumMod val="95000"/>
+              </a:schemeClr>
+            </a:solidFill>
+          </a:ln>
+          <a:effectLst>
+            <a:outerShdw blurRad="50800" dist="38100" algn="l" rotWithShape="0">
+              <a:prstClr val="black">
+                <a:alpha val="40000"/>
+              </a:prstClr>
+            </a:outerShdw>
+          </a:effectLst>
+        </p:spPr>
+        <p:style>
+          <a:lnRef idx="2">
+            <a:schemeClr val="dk1"/>
+          </a:lnRef>
+          <a:fillRef idx="1">
+            <a:schemeClr val="lt1"/>
+          </a:fillRef>
+          <a:effectRef idx="0">
+            <a:schemeClr val="dk1"/>
+          </a:effectRef>
+          <a:fontRef idx="minor">
+            <a:schemeClr val="dk1"/>
+          </a:fontRef>
+        </p:style>
+        <p:txBody>
+          <a:bodyPr wrap="square">
+            <a:spAutoFit/>
+          </a:bodyPr>
+          <a:lstStyle/>
+          <a:p>
+            <a:pPr>
+              <a:lnSpc>
+                <a:spcPct val="150000"/>
+              </a:lnSpc>
+            </a:pPr>
+            <a:r>
+              <a:rPr lang="en-GB" sz="1800" b="1" dirty="0" err="1">
+                <a:solidFill>
+                  <a:srgbClr val="000000"/>
+                </a:solidFill>
+                <a:latin typeface="Consolas" panose="020B0609020204030204" pitchFamily="49" charset="0"/>
+              </a:rPr>
+              <a:t>info.innerHTML</a:t>
+            </a:r>
+            <a:r>
+              <a:rPr lang="en-GB" sz="1800" b="1" dirty="0">
+                <a:solidFill>
+                  <a:srgbClr val="000000"/>
+                </a:solidFill>
+                <a:latin typeface="Consolas" panose="020B0609020204030204" pitchFamily="49" charset="0"/>
+              </a:rPr>
+              <a:t> = </a:t>
+            </a:r>
+            <a:r>
+              <a:rPr lang="en-GB" sz="1800" b="1" dirty="0">
+                <a:solidFill>
+                  <a:srgbClr val="A31515"/>
+                </a:solidFill>
+                <a:latin typeface="Consolas" panose="020B0609020204030204" pitchFamily="49" charset="0"/>
+              </a:rPr>
+              <a:t>"&lt;h3&gt;</a:t>
+            </a:r>
+            <a:r>
+              <a:rPr lang="en-GB" sz="1800" b="1" dirty="0">
+                <a:solidFill>
+                  <a:schemeClr val="tx1"/>
+                </a:solidFill>
+                <a:latin typeface="Consolas" panose="020B0609020204030204" pitchFamily="49" charset="0"/>
+              </a:rPr>
+              <a:t>QA</a:t>
+            </a:r>
+            <a:r>
+              <a:rPr lang="en-GB" sz="1800" b="1" dirty="0">
+                <a:solidFill>
+                  <a:srgbClr val="A31515"/>
+                </a:solidFill>
+                <a:latin typeface="Consolas" panose="020B0609020204030204" pitchFamily="49" charset="0"/>
+              </a:rPr>
+              <a:t>&lt;/h3&gt;"</a:t>
+            </a:r>
+            <a:r>
+              <a:rPr lang="en-GB" sz="1800" b="1" dirty="0">
+                <a:solidFill>
+                  <a:srgbClr val="000000"/>
+                </a:solidFill>
+                <a:latin typeface="Consolas" panose="020B0609020204030204" pitchFamily="49" charset="0"/>
+              </a:rPr>
+              <a:t>; drinks[0].checked = </a:t>
+            </a:r>
+            <a:r>
+              <a:rPr lang="en-GB" sz="1800" b="1" dirty="0">
+                <a:solidFill>
+                  <a:srgbClr val="0000FF"/>
+                </a:solidFill>
+                <a:latin typeface="Consolas" panose="020B0609020204030204" pitchFamily="49" charset="0"/>
+              </a:rPr>
+              <a:t>true</a:t>
+            </a:r>
+            <a:r>
+              <a:rPr lang="en-GB" sz="1800" b="1" dirty="0">
+                <a:solidFill>
+                  <a:srgbClr val="000000"/>
+                </a:solidFill>
+                <a:latin typeface="Consolas" panose="020B0609020204030204" pitchFamily="49" charset="0"/>
+              </a:rPr>
+              <a:t>;</a:t>
+            </a:r>
+          </a:p>
+          <a:p>
+            <a:pPr>
+              <a:lnSpc>
+                <a:spcPct val="150000"/>
+              </a:lnSpc>
+            </a:pPr>
+            <a:r>
+              <a:rPr lang="en-GB" sz="1800" b="1" dirty="0" err="1">
+                <a:solidFill>
+                  <a:srgbClr val="000000"/>
+                </a:solidFill>
+                <a:latin typeface="Consolas" panose="020B0609020204030204" pitchFamily="49" charset="0"/>
+              </a:rPr>
+              <a:t>divs</a:t>
+            </a:r>
+            <a:r>
+              <a:rPr lang="en-GB" sz="1800" b="1" dirty="0">
+                <a:solidFill>
+                  <a:srgbClr val="000000"/>
+                </a:solidFill>
+                <a:latin typeface="Consolas" panose="020B0609020204030204" pitchFamily="49" charset="0"/>
+              </a:rPr>
+              <a:t>[0].</a:t>
+            </a:r>
+            <a:r>
+              <a:rPr lang="en-GB" sz="1800" b="1" dirty="0" err="1">
+                <a:solidFill>
+                  <a:srgbClr val="000000"/>
+                </a:solidFill>
+                <a:latin typeface="Consolas" panose="020B0609020204030204" pitchFamily="49" charset="0"/>
+              </a:rPr>
+              <a:t>innerText</a:t>
+            </a:r>
+            <a:r>
+              <a:rPr lang="en-GB" sz="1800" b="1" dirty="0">
+                <a:solidFill>
+                  <a:srgbClr val="000000"/>
+                </a:solidFill>
+                <a:latin typeface="Consolas" panose="020B0609020204030204" pitchFamily="49" charset="0"/>
+              </a:rPr>
+              <a:t> = </a:t>
+            </a:r>
+            <a:r>
+              <a:rPr lang="en-GB" sz="1800" b="1" dirty="0">
+                <a:solidFill>
+                  <a:srgbClr val="A31515"/>
+                </a:solidFill>
+                <a:latin typeface="Consolas" panose="020B0609020204030204" pitchFamily="49" charset="0"/>
+              </a:rPr>
+              <a:t>"QA"</a:t>
+            </a:r>
+            <a:r>
+              <a:rPr lang="en-GB" sz="1800" b="1" dirty="0">
+                <a:solidFill>
+                  <a:srgbClr val="000000"/>
+                </a:solidFill>
+                <a:latin typeface="Consolas" panose="020B0609020204030204" pitchFamily="49" charset="0"/>
+              </a:rPr>
+              <a:t>;</a:t>
+            </a:r>
+          </a:p>
+        </p:txBody>
+      </p:sp>
+      <p:cxnSp>
+        <p:nvCxnSpPr>
+          <p:cNvPr id="20" name="Straight Arrow Connector 19">
+            <a:extLst>
+              <a:ext uri="{FF2B5EF4-FFF2-40B4-BE49-F238E27FC236}">
+                <a16:creationId xmlns:a16="http://schemas.microsoft.com/office/drawing/2014/main" id="{31DD2BC2-3E59-4F71-8146-EFEDD9FAE532}"/>
+              </a:ext>
+            </a:extLst>
+          </p:cNvPr>
+          <p:cNvCxnSpPr/>
+          <p:nvPr/>
+        </p:nvCxnSpPr>
+        <p:spPr>
+          <a:xfrm>
+            <a:off x="7344697" y="3893574"/>
+            <a:ext cx="563303" cy="0"/>
+          </a:xfrm>
+          <a:prstGeom prst="straightConnector1">
+            <a:avLst/>
+          </a:prstGeom>
+          <a:ln>
+            <a:tailEnd type="triangle"/>
+          </a:ln>
+        </p:spPr>
+        <p:style>
+          <a:lnRef idx="1">
+            <a:schemeClr val="accent1"/>
+          </a:lnRef>
+          <a:fillRef idx="0">
+            <a:schemeClr val="accent1"/>
+          </a:fillRef>
+          <a:effectRef idx="0">
+            <a:schemeClr val="accent1"/>
+          </a:effectRef>
+          <a:fontRef idx="minor">
+            <a:schemeClr val="tx1"/>
+          </a:fontRef>
+        </p:style>
+      </p:cxnSp>
+      <p:cxnSp>
+        <p:nvCxnSpPr>
+          <p:cNvPr id="21" name="Straight Arrow Connector 20">
+            <a:extLst>
+              <a:ext uri="{FF2B5EF4-FFF2-40B4-BE49-F238E27FC236}">
+                <a16:creationId xmlns:a16="http://schemas.microsoft.com/office/drawing/2014/main" id="{FA1B8F8C-FCEC-44AD-B47E-EFB6CCF51565}"/>
+              </a:ext>
+            </a:extLst>
+          </p:cNvPr>
+          <p:cNvCxnSpPr>
+            <a:cxnSpLocks/>
+          </p:cNvCxnSpPr>
+          <p:nvPr/>
+        </p:nvCxnSpPr>
+        <p:spPr>
+          <a:xfrm flipV="1">
+            <a:off x="7314688" y="4444290"/>
+            <a:ext cx="593034" cy="484217"/>
+          </a:xfrm>
+          <a:prstGeom prst="straightConnector1">
+            <a:avLst/>
+          </a:prstGeom>
+          <a:ln>
+            <a:tailEnd type="triangle"/>
+          </a:ln>
+        </p:spPr>
+        <p:style>
+          <a:lnRef idx="1">
+            <a:schemeClr val="accent1"/>
+          </a:lnRef>
+          <a:fillRef idx="0">
+            <a:schemeClr val="accent1"/>
+          </a:fillRef>
+          <a:effectRef idx="0">
+            <a:schemeClr val="accent1"/>
+          </a:effectRef>
+          <a:fontRef idx="minor">
+            <a:schemeClr val="tx1"/>
+          </a:fontRef>
+        </p:style>
+      </p:cxnSp>
+    </p:spTree>
+    <p:extLst>
+      <p:ext uri="{BB962C8B-B14F-4D97-AF65-F5344CB8AC3E}">
+        <p14:creationId xmlns:p14="http://schemas.microsoft.com/office/powerpoint/2010/main" val="1417839454"/>
+      </p:ext>
+    </p:extLst>
+  </p:cSld>
+  <p:clrMapOvr>
+    <a:masterClrMapping/>
+  </p:clrMapOvr>
+  <p:timing>
+    <p:tnLst>
+      <p:par>
+        <p:cTn id="1" dur="indefinite" restart="never" nodeType="tmRoot">
+          <p:childTnLst>
+            <p:seq concurrent="1" nextAc="seek">
+              <p:cTn id="2" dur="indefinite" nodeType="mainSeq">
+                <p:childTnLst>
+                  <p:par>
+                    <p:cTn id="3" fill="hold">
+                      <p:stCondLst>
+                        <p:cond delay="indefinite"/>
+                        <p:cond evt="onBegin" delay="0">
+                          <p:tn val="2"/>
+                        </p:cond>
+                      </p:stCondLst>
+                      <p:childTnLst>
+                        <p:par>
+                          <p:cTn id="4" fill="hold">
+                            <p:stCondLst>
+                              <p:cond delay="0"/>
+                            </p:stCondLst>
+                            <p:childTnLst>
+                              <p:par>
+                                <p:cTn id="5" presetID="10" presetClass="entr" presetSubtype="0" fill="hold" grpId="0" nodeType="withEffect">
+                                  <p:stCondLst>
+                                    <p:cond delay="0"/>
+                                  </p:stCondLst>
+                                  <p:childTnLst>
+                                    <p:set>
+                                      <p:cBhvr>
+                                        <p:cTn id="6" dur="1" fill="hold">
+                                          <p:stCondLst>
+                                            <p:cond delay="0"/>
+                                          </p:stCondLst>
+                                        </p:cTn>
+                                        <p:tgtEl>
+                                          <p:spTgt spid="17"/>
+                                        </p:tgtEl>
+                                        <p:attrNameLst>
+                                          <p:attrName>style.visibility</p:attrName>
+                                        </p:attrNameLst>
+                                      </p:cBhvr>
+                                      <p:to>
+                                        <p:strVal val="visible"/>
+                                      </p:to>
+                                    </p:set>
+                                    <p:animEffect transition="in" filter="fade">
+                                      <p:cBhvr>
+                                        <p:cTn id="7" dur="500"/>
+                                        <p:tgtEl>
+                                          <p:spTgt spid="17"/>
+                                        </p:tgtEl>
+                                      </p:cBhvr>
+                                    </p:animEffect>
+                                  </p:childTnLst>
+                                </p:cTn>
+                              </p:par>
+                              <p:par>
+                                <p:cTn id="8" presetID="10" presetClass="entr" presetSubtype="0" fill="hold" nodeType="withEffect">
+                                  <p:stCondLst>
+                                    <p:cond delay="0"/>
+                                  </p:stCondLst>
+                                  <p:childTnLst>
+                                    <p:set>
+                                      <p:cBhvr>
+                                        <p:cTn id="9" dur="1" fill="hold">
+                                          <p:stCondLst>
+                                            <p:cond delay="0"/>
+                                          </p:stCondLst>
+                                        </p:cTn>
+                                        <p:tgtEl>
+                                          <p:spTgt spid="21"/>
+                                        </p:tgtEl>
+                                        <p:attrNameLst>
+                                          <p:attrName>style.visibility</p:attrName>
+                                        </p:attrNameLst>
+                                      </p:cBhvr>
+                                      <p:to>
+                                        <p:strVal val="visible"/>
+                                      </p:to>
+                                    </p:set>
+                                    <p:animEffect transition="in" filter="fade">
+                                      <p:cBhvr>
+                                        <p:cTn id="10" dur="500"/>
+                                        <p:tgtEl>
+                                          <p:spTgt spid="21"/>
+                                        </p:tgtEl>
+                                      </p:cBhvr>
+                                    </p:animEffect>
+                                  </p:childTnLst>
+                                </p:cTn>
+                              </p:par>
+                            </p:childTnLst>
+                          </p:cTn>
+                        </p:par>
+                      </p:childTnLst>
+                    </p:cTn>
+                  </p:par>
+                </p:childTnLst>
+              </p:cTn>
+              <p:prevCondLst>
+                <p:cond evt="onPrev" delay="0">
+                  <p:tgtEl>
+                    <p:sldTgt/>
+                  </p:tgtEl>
+                </p:cond>
+              </p:prevCondLst>
+              <p:nextCondLst>
+                <p:cond evt="onNext" delay="0">
+                  <p:tgtEl>
+                    <p:sldTgt/>
+                  </p:tgtEl>
+                </p:cond>
+              </p:nextCondLst>
+            </p:seq>
+          </p:childTnLst>
+        </p:cTn>
+      </p:par>
+    </p:tnLst>
+    <p:bldLst>
+      <p:bldP spid="17" grpId="0" animBg="1"/>
+    </p:bldLst>
+  </p:timing>
+</p:sld>
+</file>
+
+<file path=ppt/slides/slide9.xml><?xml version="1.0" encoding="utf-8"?>
+<p:sld xmlns:a="http://schemas.openxmlformats.org/drawingml/2006/main" xmlns:r="http://schemas.openxmlformats.org/officeDocument/2006/relationships" xmlns:p="http://schemas.openxmlformats.org/presentationml/2006/main">
+  <p:cSld>
+    <p:spTree>
+      <p:nvGrpSpPr>
+        <p:cNvPr id="1" name=""/>
+        <p:cNvGrpSpPr/>
+        <p:nvPr/>
+      </p:nvGrpSpPr>
+      <p:grpSpPr>
+        <a:xfrm>
+          <a:off x="0" y="0"/>
+          <a:ext cx="0" cy="0"/>
+          <a:chOff x="0" y="0"/>
+          <a:chExt cx="0" cy="0"/>
+        </a:xfrm>
+      </p:grpSpPr>
+      <p:sp>
+        <p:nvSpPr>
           <p:cNvPr id="18434" name="Rectangle 5"/>
           <p:cNvSpPr>
             <a:spLocks noGrp="1" noChangeArrowheads="1"/>
@@ -36728,913 +39497,6 @@
     <p:extLst>
       <p:ext uri="{BB962C8B-B14F-4D97-AF65-F5344CB8AC3E}">
         <p14:creationId xmlns:p14="http://schemas.microsoft.com/office/powerpoint/2010/main" val="1784894733"/>
-      </p:ext>
-    </p:extLst>
-  </p:cSld>
-  <p:clrMapOvr>
-    <a:masterClrMapping/>
-  </p:clrMapOvr>
-</p:sld>
-</file>
-
-<file path=ppt/slides/slide9.xml><?xml version="1.0" encoding="utf-8"?>
-<p:sld xmlns:a="http://schemas.openxmlformats.org/drawingml/2006/main" xmlns:r="http://schemas.openxmlformats.org/officeDocument/2006/relationships" xmlns:p="http://schemas.openxmlformats.org/presentationml/2006/main">
-  <p:cSld>
-    <p:spTree>
-      <p:nvGrpSpPr>
-        <p:cNvPr id="1" name=""/>
-        <p:cNvGrpSpPr/>
-        <p:nvPr/>
-      </p:nvGrpSpPr>
-      <p:grpSpPr>
-        <a:xfrm>
-          <a:off x="0" y="0"/>
-          <a:ext cx="0" cy="0"/>
-          <a:chOff x="0" y="0"/>
-          <a:chExt cx="0" cy="0"/>
-        </a:xfrm>
-      </p:grpSpPr>
-      <p:sp>
-        <p:nvSpPr>
-          <p:cNvPr id="18434" name="Rectangle 5"/>
-          <p:cNvSpPr>
-            <a:spLocks noGrp="1" noChangeArrowheads="1"/>
-          </p:cNvSpPr>
-          <p:nvPr>
-            <p:ph type="title"/>
-          </p:nvPr>
-        </p:nvSpPr>
-        <p:spPr/>
-        <p:txBody>
-          <a:bodyPr/>
-          <a:lstStyle/>
-          <a:p>
-            <a:r>
-              <a:rPr lang="en-US" dirty="0"/>
-              <a:t>Changing multiple styles of an element</a:t>
-            </a:r>
-          </a:p>
-        </p:txBody>
-      </p:sp>
-      <p:sp>
-        <p:nvSpPr>
-          <p:cNvPr id="18435" name="Rectangle 6"/>
-          <p:cNvSpPr>
-            <a:spLocks noGrp="1" noChangeArrowheads="1"/>
-          </p:cNvSpPr>
-          <p:nvPr>
-            <p:ph idx="1"/>
-          </p:nvPr>
-        </p:nvSpPr>
-        <p:spPr/>
-        <p:txBody>
-          <a:bodyPr/>
-          <a:lstStyle/>
-          <a:p>
-            <a:pPr marL="684000" lvl="1" indent="-342000">
-              <a:buFont typeface="Arial" panose="020B0604020202020204" pitchFamily="34" charset="0"/>
-              <a:buChar char="•"/>
-            </a:pPr>
-            <a:endParaRPr lang="en-GB" dirty="0">
-              <a:latin typeface="Arial" charset="0"/>
-              <a:ea typeface="Arial" charset="0"/>
-              <a:cs typeface="Arial" charset="0"/>
-            </a:endParaRPr>
-          </a:p>
-          <a:p>
-            <a:pPr marL="684000" lvl="1" indent="-342000">
-              <a:buFont typeface="Arial" panose="020B0604020202020204" pitchFamily="34" charset="0"/>
-              <a:buChar char="•"/>
-            </a:pPr>
-            <a:endParaRPr lang="en-GB" dirty="0">
-              <a:latin typeface="Arial" charset="0"/>
-              <a:ea typeface="Arial" charset="0"/>
-              <a:cs typeface="Arial" charset="0"/>
-            </a:endParaRPr>
-          </a:p>
-          <a:p>
-            <a:pPr marL="684000" lvl="1" indent="-342000">
-              <a:buFont typeface="Arial" panose="020B0604020202020204" pitchFamily="34" charset="0"/>
-              <a:buChar char="•"/>
-            </a:pPr>
-            <a:endParaRPr lang="en-GB" dirty="0">
-              <a:latin typeface="Arial" charset="0"/>
-              <a:ea typeface="Arial" charset="0"/>
-              <a:cs typeface="Arial" charset="0"/>
-            </a:endParaRPr>
-          </a:p>
-          <a:p>
-            <a:pPr marL="684000" lvl="1" indent="-342000">
-              <a:buFont typeface="Arial" panose="020B0604020202020204" pitchFamily="34" charset="0"/>
-              <a:buChar char="•"/>
-            </a:pPr>
-            <a:endParaRPr lang="en-GB" dirty="0">
-              <a:latin typeface="Arial" charset="0"/>
-              <a:ea typeface="Arial" charset="0"/>
-              <a:cs typeface="Arial" charset="0"/>
-            </a:endParaRPr>
-          </a:p>
-          <a:p>
-            <a:pPr marL="684000" lvl="1" indent="-342000">
-              <a:buFont typeface="Arial" panose="020B0604020202020204" pitchFamily="34" charset="0"/>
-              <a:buChar char="•"/>
-            </a:pPr>
-            <a:endParaRPr lang="en-GB" dirty="0">
-              <a:latin typeface="Arial" charset="0"/>
-              <a:ea typeface="Arial" charset="0"/>
-              <a:cs typeface="Arial" charset="0"/>
-            </a:endParaRPr>
-          </a:p>
-          <a:p>
-            <a:pPr marL="684000" lvl="1" indent="-342000">
-              <a:buFont typeface="Arial" panose="020B0604020202020204" pitchFamily="34" charset="0"/>
-              <a:buChar char="•"/>
-            </a:pPr>
-            <a:endParaRPr lang="en-GB" dirty="0">
-              <a:latin typeface="Arial" charset="0"/>
-              <a:ea typeface="Arial" charset="0"/>
-              <a:cs typeface="Arial" charset="0"/>
-            </a:endParaRPr>
-          </a:p>
-          <a:p>
-            <a:pPr marL="684000" lvl="1" indent="-342000">
-              <a:buFont typeface="Arial" panose="020B0604020202020204" pitchFamily="34" charset="0"/>
-              <a:buChar char="•"/>
-            </a:pPr>
-            <a:endParaRPr lang="en-GB" dirty="0">
-              <a:latin typeface="Arial" charset="0"/>
-              <a:ea typeface="Arial" charset="0"/>
-              <a:cs typeface="Arial" charset="0"/>
-            </a:endParaRPr>
-          </a:p>
-          <a:p>
-            <a:pPr marL="684000" lvl="1" indent="-342000">
-              <a:buSzPct val="115000"/>
-              <a:buFont typeface="Arial" panose="020B0604020202020204" pitchFamily="34" charset="0"/>
-              <a:buChar char="•"/>
-            </a:pPr>
-            <a:r>
-              <a:rPr lang="en-GB" dirty="0">
-                <a:latin typeface="+mn-lt"/>
-                <a:ea typeface="Arial" charset="0"/>
-                <a:cs typeface="Arial" charset="0"/>
-              </a:rPr>
-              <a:t>The</a:t>
-            </a:r>
-            <a:r>
-              <a:rPr lang="en-GB" dirty="0">
-                <a:latin typeface="Arial" charset="0"/>
-                <a:ea typeface="Arial" charset="0"/>
-                <a:cs typeface="Arial" charset="0"/>
-              </a:rPr>
-              <a:t> </a:t>
-            </a:r>
-            <a:r>
-              <a:rPr lang="en-GB" dirty="0" err="1">
-                <a:latin typeface="Lucida Console" charset="0"/>
-                <a:ea typeface="Lucida Console" charset="0"/>
-                <a:cs typeface="Lucida Console" charset="0"/>
-              </a:rPr>
-              <a:t>className</a:t>
-            </a:r>
-            <a:r>
-              <a:rPr lang="en-GB" dirty="0">
-                <a:latin typeface="Arial" charset="0"/>
-                <a:ea typeface="Arial" charset="0"/>
-                <a:cs typeface="Arial" charset="0"/>
-              </a:rPr>
-              <a:t> can only set a single class and it will overwrite previous classes!</a:t>
-            </a:r>
-            <a:endParaRPr lang="en-GB" dirty="0">
-              <a:latin typeface="+mn-lt"/>
-              <a:ea typeface="Arial" charset="0"/>
-              <a:cs typeface="Arial" charset="0"/>
-            </a:endParaRPr>
-          </a:p>
-          <a:p>
-            <a:pPr marL="684000" lvl="1" indent="-342000">
-              <a:buSzPct val="115000"/>
-              <a:buFont typeface="Arial" panose="020B0604020202020204" pitchFamily="34" charset="0"/>
-              <a:buChar char="•"/>
-            </a:pPr>
-            <a:r>
-              <a:rPr lang="en-GB" dirty="0" err="1">
-                <a:latin typeface="+mn-lt"/>
-                <a:ea typeface="Arial" charset="0"/>
-                <a:cs typeface="Arial" charset="0"/>
-              </a:rPr>
-              <a:t>classList</a:t>
-            </a:r>
-            <a:r>
-              <a:rPr lang="en-GB" dirty="0">
-                <a:latin typeface="+mn-lt"/>
-                <a:ea typeface="Arial" charset="0"/>
-                <a:cs typeface="Arial" charset="0"/>
-              </a:rPr>
-              <a:t> enables you to apply multiple styles by using code</a:t>
-            </a:r>
-          </a:p>
-        </p:txBody>
-      </p:sp>
-      <p:sp>
-        <p:nvSpPr>
-          <p:cNvPr id="4" name="TextBox 3">
-            <a:extLst>
-              <a:ext uri="{FF2B5EF4-FFF2-40B4-BE49-F238E27FC236}">
-                <a16:creationId xmlns:a16="http://schemas.microsoft.com/office/drawing/2014/main" id="{59248DC2-AC12-5660-A3A6-C4C067E6A4BA}"/>
-              </a:ext>
-            </a:extLst>
-          </p:cNvPr>
-          <p:cNvSpPr txBox="1"/>
-          <p:nvPr/>
-        </p:nvSpPr>
-        <p:spPr>
-          <a:xfrm>
-            <a:off x="586807" y="1517054"/>
-            <a:ext cx="7215648" cy="2031325"/>
-          </a:xfrm>
-          <a:prstGeom prst="rect">
-            <a:avLst/>
-          </a:prstGeom>
-          <a:solidFill>
-            <a:schemeClr val="accent5">
-              <a:lumMod val="20000"/>
-              <a:lumOff val="80000"/>
-            </a:schemeClr>
-          </a:solidFill>
-          <a:effectLst>
-            <a:outerShdw blurRad="50800" dist="38100" algn="l" rotWithShape="0">
-              <a:prstClr val="black">
-                <a:alpha val="40000"/>
-              </a:prstClr>
-            </a:outerShdw>
-          </a:effectLst>
-        </p:spPr>
-        <p:style>
-          <a:lnRef idx="2">
-            <a:schemeClr val="dk1"/>
-          </a:lnRef>
-          <a:fillRef idx="1">
-            <a:schemeClr val="lt1"/>
-          </a:fillRef>
-          <a:effectRef idx="0">
-            <a:schemeClr val="dk1"/>
-          </a:effectRef>
-          <a:fontRef idx="minor">
-            <a:schemeClr val="dk1"/>
-          </a:fontRef>
-        </p:style>
-        <p:txBody>
-          <a:bodyPr wrap="square">
-            <a:spAutoFit/>
-          </a:bodyPr>
-          <a:lstStyle/>
-          <a:p>
-            <a:r>
-              <a:rPr lang="en-GB" sz="1800" b="1" dirty="0">
-                <a:solidFill>
-                  <a:srgbClr val="0000FF"/>
-                </a:solidFill>
-                <a:latin typeface="Consolas" panose="020B0609020204030204" pitchFamily="49" charset="0"/>
-              </a:rPr>
-              <a:t>&lt;</a:t>
-            </a:r>
-            <a:r>
-              <a:rPr lang="en-GB" sz="1800" b="1" dirty="0">
-                <a:solidFill>
-                  <a:srgbClr val="800000"/>
-                </a:solidFill>
-                <a:latin typeface="Consolas" panose="020B0609020204030204" pitchFamily="49" charset="0"/>
-              </a:rPr>
-              <a:t>div</a:t>
-            </a:r>
-            <a:r>
-              <a:rPr lang="en-GB" sz="1800" b="1" dirty="0">
-                <a:solidFill>
-                  <a:srgbClr val="000000"/>
-                </a:solidFill>
-                <a:latin typeface="Consolas" panose="020B0609020204030204" pitchFamily="49" charset="0"/>
-              </a:rPr>
-              <a:t> </a:t>
-            </a:r>
-            <a:r>
-              <a:rPr lang="en-GB" sz="1800" b="1" dirty="0">
-                <a:solidFill>
-                  <a:srgbClr val="FF0000"/>
-                </a:solidFill>
-                <a:latin typeface="Consolas" panose="020B0609020204030204" pitchFamily="49" charset="0"/>
-              </a:rPr>
-              <a:t>id</a:t>
-            </a:r>
-            <a:r>
-              <a:rPr lang="en-GB" sz="1800" b="1" dirty="0">
-                <a:solidFill>
-                  <a:srgbClr val="0000FF"/>
-                </a:solidFill>
-                <a:latin typeface="Consolas" panose="020B0609020204030204" pitchFamily="49" charset="0"/>
-              </a:rPr>
-              <a:t>="hello"&gt;</a:t>
-            </a:r>
-            <a:r>
-              <a:rPr lang="en-GB" sz="1800" b="1" dirty="0">
-                <a:solidFill>
-                  <a:srgbClr val="000000"/>
-                </a:solidFill>
-                <a:latin typeface="Consolas" panose="020B0609020204030204" pitchFamily="49" charset="0"/>
-              </a:rPr>
-              <a:t>Hello world</a:t>
-            </a:r>
-            <a:r>
-              <a:rPr lang="en-GB" sz="1800" b="1" dirty="0">
-                <a:solidFill>
-                  <a:srgbClr val="0000FF"/>
-                </a:solidFill>
-                <a:latin typeface="Consolas" panose="020B0609020204030204" pitchFamily="49" charset="0"/>
-              </a:rPr>
-              <a:t>&lt;/</a:t>
-            </a:r>
-            <a:r>
-              <a:rPr lang="en-GB" sz="1800" b="1" dirty="0">
-                <a:solidFill>
-                  <a:srgbClr val="800000"/>
-                </a:solidFill>
-                <a:latin typeface="Consolas" panose="020B0609020204030204" pitchFamily="49" charset="0"/>
-              </a:rPr>
-              <a:t>div</a:t>
-            </a:r>
-            <a:r>
-              <a:rPr lang="en-GB" sz="1800" b="1" dirty="0">
-                <a:solidFill>
-                  <a:srgbClr val="0000FF"/>
-                </a:solidFill>
-                <a:latin typeface="Consolas" panose="020B0609020204030204" pitchFamily="49" charset="0"/>
-              </a:rPr>
-              <a:t>&gt;</a:t>
-            </a:r>
-            <a:endParaRPr lang="en-GB" sz="1800" b="1" dirty="0">
-              <a:solidFill>
-                <a:srgbClr val="000000"/>
-              </a:solidFill>
-              <a:latin typeface="Consolas" panose="020B0609020204030204" pitchFamily="49" charset="0"/>
-            </a:endParaRPr>
-          </a:p>
-          <a:p>
-            <a:endParaRPr lang="en-GB" sz="1800" b="1" dirty="0">
-              <a:solidFill>
-                <a:srgbClr val="000000"/>
-              </a:solidFill>
-              <a:latin typeface="Consolas" panose="020B0609020204030204" pitchFamily="49" charset="0"/>
-            </a:endParaRPr>
-          </a:p>
-          <a:p>
-            <a:r>
-              <a:rPr lang="en-GB" sz="1800" b="1" dirty="0">
-                <a:solidFill>
-                  <a:srgbClr val="0000FF"/>
-                </a:solidFill>
-                <a:latin typeface="Consolas" panose="020B0609020204030204" pitchFamily="49" charset="0"/>
-              </a:rPr>
-              <a:t>&lt;</a:t>
-            </a:r>
-            <a:r>
-              <a:rPr lang="en-GB" sz="1800" b="1" dirty="0">
-                <a:solidFill>
-                  <a:srgbClr val="800000"/>
-                </a:solidFill>
-                <a:latin typeface="Consolas" panose="020B0609020204030204" pitchFamily="49" charset="0"/>
-              </a:rPr>
-              <a:t>script</a:t>
-            </a:r>
-            <a:r>
-              <a:rPr lang="en-GB" sz="1800" b="1" dirty="0">
-                <a:solidFill>
-                  <a:srgbClr val="0000FF"/>
-                </a:solidFill>
-                <a:latin typeface="Consolas" panose="020B0609020204030204" pitchFamily="49" charset="0"/>
-              </a:rPr>
-              <a:t>&gt;</a:t>
-            </a:r>
-            <a:endParaRPr lang="en-GB" sz="1800" b="1" dirty="0">
-              <a:solidFill>
-                <a:srgbClr val="000000"/>
-              </a:solidFill>
-              <a:latin typeface="Consolas" panose="020B0609020204030204" pitchFamily="49" charset="0"/>
-            </a:endParaRPr>
-          </a:p>
-          <a:p>
-            <a:r>
-              <a:rPr lang="en-GB" sz="1800" b="1" dirty="0">
-                <a:solidFill>
-                  <a:srgbClr val="0000FF"/>
-                </a:solidFill>
-                <a:latin typeface="Consolas" panose="020B0609020204030204" pitchFamily="49" charset="0"/>
-              </a:rPr>
-              <a:t>    let</a:t>
-            </a:r>
-            <a:r>
-              <a:rPr lang="en-GB" sz="1800" b="1" dirty="0">
-                <a:solidFill>
-                  <a:srgbClr val="000000"/>
-                </a:solidFill>
-                <a:latin typeface="Consolas" panose="020B0609020204030204" pitchFamily="49" charset="0"/>
-              </a:rPr>
-              <a:t> div1 = </a:t>
-            </a:r>
-            <a:r>
-              <a:rPr lang="en-GB" sz="1800" b="1" dirty="0" err="1">
-                <a:solidFill>
-                  <a:srgbClr val="000000"/>
-                </a:solidFill>
-                <a:latin typeface="Consolas" panose="020B0609020204030204" pitchFamily="49" charset="0"/>
-              </a:rPr>
-              <a:t>document.getElementById</a:t>
-            </a:r>
-            <a:r>
-              <a:rPr lang="en-GB" sz="1800" b="1" dirty="0">
-                <a:solidFill>
-                  <a:srgbClr val="000000"/>
-                </a:solidFill>
-                <a:latin typeface="Consolas" panose="020B0609020204030204" pitchFamily="49" charset="0"/>
-              </a:rPr>
-              <a:t>(</a:t>
-            </a:r>
-            <a:r>
-              <a:rPr lang="en-GB" sz="1800" b="1" dirty="0">
-                <a:solidFill>
-                  <a:srgbClr val="A31515"/>
-                </a:solidFill>
-                <a:latin typeface="Consolas" panose="020B0609020204030204" pitchFamily="49" charset="0"/>
-              </a:rPr>
-              <a:t>"hello"</a:t>
-            </a:r>
-            <a:r>
-              <a:rPr lang="en-GB" sz="1800" b="1" dirty="0">
-                <a:solidFill>
-                  <a:srgbClr val="000000"/>
-                </a:solidFill>
-                <a:latin typeface="Consolas" panose="020B0609020204030204" pitchFamily="49" charset="0"/>
-              </a:rPr>
-              <a:t>);</a:t>
-            </a:r>
-          </a:p>
-          <a:p>
-            <a:r>
-              <a:rPr lang="en-GB" b="1" dirty="0">
-                <a:solidFill>
-                  <a:srgbClr val="000000"/>
-                </a:solidFill>
-                <a:latin typeface="Consolas" panose="020B0609020204030204" pitchFamily="49" charset="0"/>
-              </a:rPr>
-              <a:t>    </a:t>
-            </a:r>
-            <a:r>
-              <a:rPr lang="en-GB" sz="1800" b="1" dirty="0">
-                <a:solidFill>
-                  <a:srgbClr val="000000"/>
-                </a:solidFill>
-                <a:latin typeface="Consolas" panose="020B0609020204030204" pitchFamily="49" charset="0"/>
-              </a:rPr>
-              <a:t>div1.classList.add(</a:t>
-            </a:r>
-            <a:r>
-              <a:rPr lang="en-GB" sz="1800" b="1" dirty="0">
-                <a:solidFill>
-                  <a:srgbClr val="A31515"/>
-                </a:solidFill>
-                <a:latin typeface="Consolas" panose="020B0609020204030204" pitchFamily="49" charset="0"/>
-              </a:rPr>
-              <a:t>"hello")</a:t>
-            </a:r>
-            <a:r>
-              <a:rPr lang="en-GB" sz="1800" b="1" dirty="0">
-                <a:solidFill>
-                  <a:srgbClr val="000000"/>
-                </a:solidFill>
-                <a:latin typeface="Consolas" panose="020B0609020204030204" pitchFamily="49" charset="0"/>
-              </a:rPr>
-              <a:t>;</a:t>
-            </a:r>
-          </a:p>
-          <a:p>
-            <a:r>
-              <a:rPr lang="en-GB" b="1" dirty="0">
-                <a:solidFill>
-                  <a:srgbClr val="000000"/>
-                </a:solidFill>
-                <a:latin typeface="Consolas" panose="020B0609020204030204" pitchFamily="49" charset="0"/>
-              </a:rPr>
-              <a:t>    </a:t>
-            </a:r>
-            <a:r>
-              <a:rPr lang="en-GB" sz="1800" b="1" dirty="0">
-                <a:solidFill>
-                  <a:srgbClr val="000000"/>
-                </a:solidFill>
-                <a:latin typeface="Consolas" panose="020B0609020204030204" pitchFamily="49" charset="0"/>
-              </a:rPr>
-              <a:t>div1.classList.add(</a:t>
-            </a:r>
-            <a:r>
-              <a:rPr lang="en-GB" sz="1800" b="1" dirty="0">
-                <a:solidFill>
-                  <a:srgbClr val="A31515"/>
-                </a:solidFill>
-                <a:latin typeface="Consolas" panose="020B0609020204030204" pitchFamily="49" charset="0"/>
-              </a:rPr>
-              <a:t>"note")</a:t>
-            </a:r>
-            <a:r>
-              <a:rPr lang="en-GB" sz="1800" b="1" dirty="0">
-                <a:solidFill>
-                  <a:srgbClr val="000000"/>
-                </a:solidFill>
-                <a:latin typeface="Consolas" panose="020B0609020204030204" pitchFamily="49" charset="0"/>
-              </a:rPr>
-              <a:t>;</a:t>
-            </a:r>
-          </a:p>
-          <a:p>
-            <a:r>
-              <a:rPr lang="en-GB" sz="1800" b="1" dirty="0">
-                <a:solidFill>
-                  <a:srgbClr val="0000FF"/>
-                </a:solidFill>
-                <a:latin typeface="Consolas" panose="020B0609020204030204" pitchFamily="49" charset="0"/>
-              </a:rPr>
-              <a:t>&lt;/</a:t>
-            </a:r>
-            <a:r>
-              <a:rPr lang="en-GB" sz="1800" b="1" dirty="0">
-                <a:solidFill>
-                  <a:srgbClr val="800000"/>
-                </a:solidFill>
-                <a:latin typeface="Consolas" panose="020B0609020204030204" pitchFamily="49" charset="0"/>
-              </a:rPr>
-              <a:t>script</a:t>
-            </a:r>
-            <a:r>
-              <a:rPr lang="en-GB" sz="1800" b="1" dirty="0">
-                <a:solidFill>
-                  <a:srgbClr val="0000FF"/>
-                </a:solidFill>
-                <a:latin typeface="Consolas" panose="020B0609020204030204" pitchFamily="49" charset="0"/>
-              </a:rPr>
-              <a:t>&gt;</a:t>
-            </a:r>
-            <a:endParaRPr lang="en-GB" sz="1800" b="1" dirty="0">
-              <a:solidFill>
-                <a:srgbClr val="000000"/>
-              </a:solidFill>
-              <a:latin typeface="Consolas" panose="020B0609020204030204" pitchFamily="49" charset="0"/>
-            </a:endParaRPr>
-          </a:p>
-        </p:txBody>
-      </p:sp>
-      <p:sp>
-        <p:nvSpPr>
-          <p:cNvPr id="3" name="TextBox 2">
-            <a:extLst>
-              <a:ext uri="{FF2B5EF4-FFF2-40B4-BE49-F238E27FC236}">
-                <a16:creationId xmlns:a16="http://schemas.microsoft.com/office/drawing/2014/main" id="{08F27F98-9930-69AF-5242-87E30D55BEB1}"/>
-              </a:ext>
-            </a:extLst>
-          </p:cNvPr>
-          <p:cNvSpPr txBox="1"/>
-          <p:nvPr/>
-        </p:nvSpPr>
-        <p:spPr>
-          <a:xfrm>
-            <a:off x="7960900" y="1517054"/>
-            <a:ext cx="3997000" cy="2092881"/>
-          </a:xfrm>
-          <a:prstGeom prst="rect">
-            <a:avLst/>
-          </a:prstGeom>
-          <a:solidFill>
-            <a:schemeClr val="tx1">
-              <a:lumMod val="10000"/>
-              <a:lumOff val="90000"/>
-            </a:schemeClr>
-          </a:solidFill>
-          <a:ln>
-            <a:solidFill>
-              <a:schemeClr val="tx1"/>
-            </a:solidFill>
-          </a:ln>
-          <a:effectLst>
-            <a:outerShdw blurRad="50800" dist="38100" dir="2700000" algn="tl" rotWithShape="0">
-              <a:prstClr val="black">
-                <a:alpha val="40000"/>
-              </a:prstClr>
-            </a:outerShdw>
-          </a:effectLst>
-        </p:spPr>
-        <p:style>
-          <a:lnRef idx="2">
-            <a:schemeClr val="dk1"/>
-          </a:lnRef>
-          <a:fillRef idx="1">
-            <a:schemeClr val="lt1"/>
-          </a:fillRef>
-          <a:effectRef idx="0">
-            <a:schemeClr val="dk1"/>
-          </a:effectRef>
-          <a:fontRef idx="minor">
-            <a:schemeClr val="dk1"/>
-          </a:fontRef>
-        </p:style>
-        <p:txBody>
-          <a:bodyPr wrap="square">
-            <a:spAutoFit/>
-          </a:bodyPr>
-          <a:lstStyle/>
-          <a:p>
-            <a:r>
-              <a:rPr lang="en-GB" sz="1600" b="1" dirty="0">
-                <a:solidFill>
-                  <a:srgbClr val="0000FF"/>
-                </a:solidFill>
-                <a:latin typeface="Consolas" panose="020B0609020204030204" pitchFamily="49" charset="0"/>
-              </a:rPr>
-              <a:t>&lt;</a:t>
-            </a:r>
-            <a:r>
-              <a:rPr lang="en-GB" sz="1600" b="1" dirty="0">
-                <a:solidFill>
-                  <a:srgbClr val="800000"/>
-                </a:solidFill>
-                <a:latin typeface="Consolas" panose="020B0609020204030204" pitchFamily="49" charset="0"/>
-              </a:rPr>
-              <a:t>style</a:t>
-            </a:r>
-            <a:r>
-              <a:rPr lang="en-GB" sz="1600" b="1" dirty="0">
-                <a:solidFill>
-                  <a:srgbClr val="0000FF"/>
-                </a:solidFill>
-                <a:latin typeface="Consolas" panose="020B0609020204030204" pitchFamily="49" charset="0"/>
-              </a:rPr>
-              <a:t>&gt;</a:t>
-            </a:r>
-            <a:endParaRPr lang="en-GB" sz="1600" b="1" dirty="0">
-              <a:solidFill>
-                <a:srgbClr val="000000"/>
-              </a:solidFill>
-              <a:latin typeface="Consolas" panose="020B0609020204030204" pitchFamily="49" charset="0"/>
-            </a:endParaRPr>
-          </a:p>
-          <a:p>
-            <a:r>
-              <a:rPr lang="en-GB" sz="1600" b="1" dirty="0">
-                <a:solidFill>
-                  <a:srgbClr val="000000"/>
-                </a:solidFill>
-                <a:latin typeface="Consolas" panose="020B0609020204030204" pitchFamily="49" charset="0"/>
-              </a:rPr>
-              <a:t> </a:t>
-            </a:r>
-            <a:r>
-              <a:rPr lang="en-GB" sz="1600" b="1" dirty="0">
-                <a:solidFill>
-                  <a:srgbClr val="800000"/>
-                </a:solidFill>
-                <a:latin typeface="Consolas" panose="020B0609020204030204" pitchFamily="49" charset="0"/>
-              </a:rPr>
-              <a:t>.hello</a:t>
-            </a:r>
-            <a:r>
-              <a:rPr lang="en-GB" sz="1600" b="1" dirty="0">
-                <a:solidFill>
-                  <a:srgbClr val="000000"/>
-                </a:solidFill>
-                <a:latin typeface="Consolas" panose="020B0609020204030204" pitchFamily="49" charset="0"/>
-              </a:rPr>
-              <a:t> {</a:t>
-            </a:r>
-          </a:p>
-          <a:p>
-            <a:r>
-              <a:rPr lang="en-GB" sz="1600" b="1" dirty="0">
-                <a:solidFill>
-                  <a:srgbClr val="000000"/>
-                </a:solidFill>
-                <a:latin typeface="Consolas" panose="020B0609020204030204" pitchFamily="49" charset="0"/>
-              </a:rPr>
-              <a:t>        </a:t>
-            </a:r>
-            <a:r>
-              <a:rPr lang="en-GB" sz="1600" b="1" dirty="0">
-                <a:solidFill>
-                  <a:srgbClr val="FF0000"/>
-                </a:solidFill>
-                <a:latin typeface="Consolas" panose="020B0609020204030204" pitchFamily="49" charset="0"/>
-              </a:rPr>
-              <a:t>border</a:t>
-            </a:r>
-            <a:r>
-              <a:rPr lang="en-GB" sz="1600" b="1" dirty="0">
-                <a:solidFill>
-                  <a:srgbClr val="000000"/>
-                </a:solidFill>
-                <a:latin typeface="Consolas" panose="020B0609020204030204" pitchFamily="49" charset="0"/>
-              </a:rPr>
-              <a:t>: </a:t>
-            </a:r>
-            <a:r>
-              <a:rPr lang="en-GB" sz="1600" b="1" dirty="0">
-                <a:solidFill>
-                  <a:srgbClr val="0000FF"/>
-                </a:solidFill>
-                <a:latin typeface="Consolas" panose="020B0609020204030204" pitchFamily="49" charset="0"/>
-              </a:rPr>
-              <a:t>3px</a:t>
-            </a:r>
-            <a:r>
-              <a:rPr lang="en-GB" sz="1600" b="1" dirty="0">
-                <a:solidFill>
-                  <a:srgbClr val="000000"/>
-                </a:solidFill>
-                <a:latin typeface="Consolas" panose="020B0609020204030204" pitchFamily="49" charset="0"/>
-              </a:rPr>
-              <a:t> </a:t>
-            </a:r>
-            <a:r>
-              <a:rPr lang="en-GB" sz="1600" b="1" dirty="0">
-                <a:solidFill>
-                  <a:srgbClr val="0000FF"/>
-                </a:solidFill>
-                <a:latin typeface="Consolas" panose="020B0609020204030204" pitchFamily="49" charset="0"/>
-              </a:rPr>
-              <a:t>solid</a:t>
-            </a:r>
-            <a:r>
-              <a:rPr lang="en-GB" sz="1600" b="1" dirty="0">
-                <a:solidFill>
-                  <a:srgbClr val="000000"/>
-                </a:solidFill>
-                <a:latin typeface="Consolas" panose="020B0609020204030204" pitchFamily="49" charset="0"/>
-              </a:rPr>
-              <a:t> </a:t>
-            </a:r>
-            <a:r>
-              <a:rPr lang="en-GB" sz="1600" b="1" dirty="0">
-                <a:solidFill>
-                  <a:srgbClr val="0000FF"/>
-                </a:solidFill>
-                <a:latin typeface="Consolas" panose="020B0609020204030204" pitchFamily="49" charset="0"/>
-              </a:rPr>
-              <a:t>red</a:t>
-            </a:r>
-            <a:r>
-              <a:rPr lang="en-GB" sz="1600" b="1" dirty="0">
-                <a:solidFill>
-                  <a:srgbClr val="000000"/>
-                </a:solidFill>
-                <a:latin typeface="Consolas" panose="020B0609020204030204" pitchFamily="49" charset="0"/>
-              </a:rPr>
-              <a:t>;</a:t>
-            </a:r>
-          </a:p>
-          <a:p>
-            <a:r>
-              <a:rPr lang="en-GB" sz="1600" b="1" dirty="0">
-                <a:solidFill>
-                  <a:srgbClr val="000000"/>
-                </a:solidFill>
-                <a:latin typeface="Consolas" panose="020B0609020204030204" pitchFamily="49" charset="0"/>
-              </a:rPr>
-              <a:t>    }</a:t>
-            </a:r>
-          </a:p>
-          <a:p>
-            <a:r>
-              <a:rPr lang="en-GB" sz="1600" b="1" dirty="0">
-                <a:solidFill>
-                  <a:srgbClr val="000000"/>
-                </a:solidFill>
-                <a:latin typeface="Consolas" panose="020B0609020204030204" pitchFamily="49" charset="0"/>
-              </a:rPr>
-              <a:t> </a:t>
-            </a:r>
-            <a:r>
-              <a:rPr lang="en-GB" sz="1600" b="1" dirty="0">
-                <a:solidFill>
-                  <a:srgbClr val="800000"/>
-                </a:solidFill>
-                <a:latin typeface="Consolas" panose="020B0609020204030204" pitchFamily="49" charset="0"/>
-              </a:rPr>
-              <a:t>.note</a:t>
-            </a:r>
-            <a:r>
-              <a:rPr lang="en-GB" sz="1600" b="1" dirty="0">
-                <a:solidFill>
-                  <a:srgbClr val="000000"/>
-                </a:solidFill>
-                <a:latin typeface="Consolas" panose="020B0609020204030204" pitchFamily="49" charset="0"/>
-              </a:rPr>
-              <a:t> {</a:t>
-            </a:r>
-          </a:p>
-          <a:p>
-            <a:r>
-              <a:rPr lang="en-GB" sz="1600" b="1" dirty="0">
-                <a:solidFill>
-                  <a:srgbClr val="000000"/>
-                </a:solidFill>
-                <a:latin typeface="Consolas" panose="020B0609020204030204" pitchFamily="49" charset="0"/>
-              </a:rPr>
-              <a:t>     </a:t>
-            </a:r>
-            <a:r>
-              <a:rPr lang="en-GB" sz="1800" b="1" dirty="0">
-                <a:solidFill>
-                  <a:srgbClr val="FF0000"/>
-                </a:solidFill>
-                <a:latin typeface="Consolas" panose="020B0609020204030204" pitchFamily="49" charset="0"/>
-              </a:rPr>
-              <a:t>background-color</a:t>
-            </a:r>
-            <a:r>
-              <a:rPr lang="en-GB" sz="1800" b="1" dirty="0">
-                <a:solidFill>
-                  <a:srgbClr val="000000"/>
-                </a:solidFill>
-                <a:latin typeface="Consolas" panose="020B0609020204030204" pitchFamily="49" charset="0"/>
-              </a:rPr>
-              <a:t>: </a:t>
-            </a:r>
-            <a:r>
-              <a:rPr lang="en-GB" sz="1800" b="1" dirty="0">
-                <a:solidFill>
-                  <a:srgbClr val="0000FF"/>
-                </a:solidFill>
-                <a:latin typeface="Consolas" panose="020B0609020204030204" pitchFamily="49" charset="0"/>
-              </a:rPr>
-              <a:t>yellow</a:t>
-            </a:r>
-            <a:r>
-              <a:rPr lang="en-GB" sz="1800" b="1" dirty="0">
-                <a:solidFill>
-                  <a:srgbClr val="000000"/>
-                </a:solidFill>
-                <a:latin typeface="Consolas" panose="020B0609020204030204" pitchFamily="49" charset="0"/>
-              </a:rPr>
-              <a:t>;</a:t>
-            </a:r>
-            <a:endParaRPr lang="en-GB" sz="1600" b="1" dirty="0">
-              <a:solidFill>
-                <a:srgbClr val="000000"/>
-              </a:solidFill>
-              <a:latin typeface="Consolas" panose="020B0609020204030204" pitchFamily="49" charset="0"/>
-            </a:endParaRPr>
-          </a:p>
-          <a:p>
-            <a:r>
-              <a:rPr lang="en-GB" sz="1600" b="1" dirty="0">
-                <a:solidFill>
-                  <a:srgbClr val="000000"/>
-                </a:solidFill>
-                <a:latin typeface="Consolas" panose="020B0609020204030204" pitchFamily="49" charset="0"/>
-              </a:rPr>
-              <a:t>    }</a:t>
-            </a:r>
-          </a:p>
-          <a:p>
-            <a:r>
-              <a:rPr lang="en-GB" sz="1600" b="1" dirty="0">
-                <a:solidFill>
-                  <a:srgbClr val="0000FF"/>
-                </a:solidFill>
-                <a:latin typeface="Consolas" panose="020B0609020204030204" pitchFamily="49" charset="0"/>
-              </a:rPr>
-              <a:t>&lt;/</a:t>
-            </a:r>
-            <a:r>
-              <a:rPr lang="en-GB" sz="1600" b="1" dirty="0">
-                <a:solidFill>
-                  <a:srgbClr val="800000"/>
-                </a:solidFill>
-                <a:latin typeface="Consolas" panose="020B0609020204030204" pitchFamily="49" charset="0"/>
-              </a:rPr>
-              <a:t>style</a:t>
-            </a:r>
-            <a:r>
-              <a:rPr lang="en-GB" sz="1600" b="1" dirty="0">
-                <a:solidFill>
-                  <a:srgbClr val="0000FF"/>
-                </a:solidFill>
-                <a:latin typeface="Consolas" panose="020B0609020204030204" pitchFamily="49" charset="0"/>
-              </a:rPr>
-              <a:t>&gt;</a:t>
-            </a:r>
-            <a:endParaRPr lang="en-GB" sz="1600" b="1" dirty="0"/>
-          </a:p>
-        </p:txBody>
-      </p:sp>
-    </p:spTree>
-    <p:extLst>
-      <p:ext uri="{BB962C8B-B14F-4D97-AF65-F5344CB8AC3E}">
-        <p14:creationId xmlns:p14="http://schemas.microsoft.com/office/powerpoint/2010/main" val="325324144"/>
       </p:ext>
     </p:extLst>
   </p:cSld>
@@ -38452,32 +40314,6 @@
 </file>
 
 <file path=customXml/item1.xml><?xml version="1.0" encoding="utf-8"?>
-<p:properties xmlns:p="http://schemas.microsoft.com/office/2006/metadata/properties" xmlns:xsi="http://www.w3.org/2001/XMLSchema-instance" xmlns:pc="http://schemas.microsoft.com/office/infopath/2007/PartnerControls">
-  <documentManagement>
-    <BookTypeField0 xmlns="B42EA499-AA80-4ED5-9ED5-37A17D3EB549">
-      <Terms xmlns="http://schemas.microsoft.com/office/infopath/2007/PartnerControls">
-        <TermInfo xmlns="http://schemas.microsoft.com/office/infopath/2007/PartnerControls">
-          <TermName xmlns="http://schemas.microsoft.com/office/infopath/2007/PartnerControls">IK</TermName>
-          <TermId xmlns="http://schemas.microsoft.com/office/infopath/2007/PartnerControls">5abe6401-e87a-4499-80b4-3d21a1a6ebd7</TermId>
-        </TermInfo>
-      </Terms>
-    </BookTypeField0>
-    <IsBuildFile xmlns="B42EA499-AA80-4ED5-9ED5-37A17D3EB549" xsi:nil="true"/>
-    <SequenceNumber xmlns="B42EA499-AA80-4ED5-9ED5-37A17D3EB549" xsi:nil="true"/>
-  </documentManagement>
-</p:properties>
-</file>
-
-<file path=customXml/item2.xml><?xml version="1.0" encoding="utf-8"?>
-<?mso-contentType ?>
-<FormTemplates xmlns="http://schemas.microsoft.com/sharepoint/v3/contenttype/forms">
-  <Display>DocumentLibraryForm</Display>
-  <Edit>DocumentLibraryForm</Edit>
-  <New>DocumentLibraryForm</New>
-</FormTemplates>
-</file>
-
-<file path=customXml/item3.xml><?xml version="1.0" encoding="utf-8"?>
 <ct:contentTypeSchema xmlns:ct="http://schemas.microsoft.com/office/2006/metadata/contentType" xmlns:ma="http://schemas.microsoft.com/office/2006/metadata/properties/metaAttributes" ct:_="" ma:_="" ma:contentTypeName="Courseware" ma:contentTypeID="0x010100F0967B7CEE8D417F966757887D9466FB005CB7CECC996A5B448C70C3215DE65491" ma:contentTypeVersion="0" ma:contentTypeDescription="Base content type which represents courseware documents" ma:contentTypeScope="" ma:versionID="633ed7bf8a9769dc10b8af609c2e65e8">
   <xsd:schema xmlns:xsd="http://www.w3.org/2001/XMLSchema" xmlns:xs="http://www.w3.org/2001/XMLSchema" xmlns:p="http://schemas.microsoft.com/office/2006/metadata/properties" xmlns:ns2="B42EA499-AA80-4ED5-9ED5-37A17D3EB549" targetNamespace="http://schemas.microsoft.com/office/2006/metadata/properties" ma:root="true" ma:fieldsID="6641bdc0935a9ffdc34b1682c1e0febc" ns2:_="">
     <xsd:import namespace="B42EA499-AA80-4ED5-9ED5-37A17D3EB549"/>
@@ -38617,25 +40453,33 @@
 </ct:contentTypeSchema>
 </file>
 
-<file path=customXml/itemProps1.xml><?xml version="1.0" encoding="utf-8"?>
-<ds:datastoreItem xmlns:ds="http://schemas.openxmlformats.org/officeDocument/2006/customXml" ds:itemID="{6276D8A5-6460-41D8-B2BB-D6C022FE8A5C}">
-  <ds:schemaRefs>
-    <ds:schemaRef ds:uri="http://schemas.microsoft.com/office/2006/metadata/properties"/>
-    <ds:schemaRef ds:uri="http://schemas.microsoft.com/office/infopath/2007/PartnerControls"/>
-    <ds:schemaRef ds:uri="B42EA499-AA80-4ED5-9ED5-37A17D3EB549"/>
-  </ds:schemaRefs>
-</ds:datastoreItem>
+<file path=customXml/item2.xml><?xml version="1.0" encoding="utf-8"?>
+<?mso-contentType ?>
+<FormTemplates xmlns="http://schemas.microsoft.com/sharepoint/v3/contenttype/forms">
+  <Display>DocumentLibraryForm</Display>
+  <Edit>DocumentLibraryForm</Edit>
+  <New>DocumentLibraryForm</New>
+</FormTemplates>
 </file>
 
-<file path=customXml/itemProps2.xml><?xml version="1.0" encoding="utf-8"?>
-<ds:datastoreItem xmlns:ds="http://schemas.openxmlformats.org/officeDocument/2006/customXml" ds:itemID="{D47B5C6E-C195-4668-928F-F519F583A6D4}">
-  <ds:schemaRefs>
-    <ds:schemaRef ds:uri="http://schemas.microsoft.com/sharepoint/v3/contenttype/forms"/>
-  </ds:schemaRefs>
-</ds:datastoreItem>
+<file path=customXml/item3.xml><?xml version="1.0" encoding="utf-8"?>
+<p:properties xmlns:p="http://schemas.microsoft.com/office/2006/metadata/properties" xmlns:xsi="http://www.w3.org/2001/XMLSchema-instance" xmlns:pc="http://schemas.microsoft.com/office/infopath/2007/PartnerControls">
+  <documentManagement>
+    <BookTypeField0 xmlns="B42EA499-AA80-4ED5-9ED5-37A17D3EB549">
+      <Terms xmlns="http://schemas.microsoft.com/office/infopath/2007/PartnerControls">
+        <TermInfo xmlns="http://schemas.microsoft.com/office/infopath/2007/PartnerControls">
+          <TermName xmlns="http://schemas.microsoft.com/office/infopath/2007/PartnerControls">IK</TermName>
+          <TermId xmlns="http://schemas.microsoft.com/office/infopath/2007/PartnerControls">5abe6401-e87a-4499-80b4-3d21a1a6ebd7</TermId>
+        </TermInfo>
+      </Terms>
+    </BookTypeField0>
+    <IsBuildFile xmlns="B42EA499-AA80-4ED5-9ED5-37A17D3EB549" xsi:nil="true"/>
+    <SequenceNumber xmlns="B42EA499-AA80-4ED5-9ED5-37A17D3EB549" xsi:nil="true"/>
+  </documentManagement>
+</p:properties>
 </file>
 
-<file path=customXml/itemProps3.xml><?xml version="1.0" encoding="utf-8"?>
+<file path=customXml/itemProps1.xml><?xml version="1.0" encoding="utf-8"?>
 <ds:datastoreItem xmlns:ds="http://schemas.openxmlformats.org/officeDocument/2006/customXml" ds:itemID="{96C7C959-319B-49E2-8C8F-A5D510E8AE2E}">
   <ds:schemaRefs>
     <ds:schemaRef ds:uri="http://schemas.microsoft.com/office/2006/metadata/contentType"/>
@@ -38651,4 +40495,22 @@
     <ds:schemaRef ds:uri="http://schemas.microsoft.com/internal/obd"/>
   </ds:schemaRefs>
 </ds:datastoreItem>
+</file>
+
+<file path=customXml/itemProps2.xml><?xml version="1.0" encoding="utf-8"?>
+<ds:datastoreItem xmlns:ds="http://schemas.openxmlformats.org/officeDocument/2006/customXml" ds:itemID="{D47B5C6E-C195-4668-928F-F519F583A6D4}">
+  <ds:schemaRefs>
+    <ds:schemaRef ds:uri="http://schemas.microsoft.com/sharepoint/v3/contenttype/forms"/>
+  </ds:schemaRefs>
+</ds:datastoreItem>
+</file>
+
+<file path=customXml/itemProps3.xml><?xml version="1.0" encoding="utf-8"?>
+<ds:datastoreItem xmlns:ds="http://schemas.openxmlformats.org/officeDocument/2006/customXml" ds:itemID="{6276D8A5-6460-41D8-B2BB-D6C022FE8A5C}">
+  <ds:schemaRefs>
+    <ds:schemaRef ds:uri="http://schemas.microsoft.com/office/2006/metadata/properties"/>
+    <ds:schemaRef ds:uri="http://schemas.microsoft.com/office/infopath/2007/PartnerControls"/>
+    <ds:schemaRef ds:uri="B42EA499-AA80-4ED5-9ED5-37A17D3EB549"/>
+  </ds:schemaRefs>
+</ds:datastoreItem>
 </file>
</xml_diff>

<commit_message>
added a React getting started slide
</commit_message>
<xml_diff>
--- a/Slides/JavaScript/09 - Accessing DOM elements.pptx
+++ b/Slides/JavaScript/09 - Accessing DOM elements.pptx
@@ -36524,7 +36524,7 @@
         <p:spPr>
           <a:xfrm>
             <a:off x="1146688" y="2551837"/>
-            <a:ext cx="7215648" cy="1754326"/>
+            <a:ext cx="8911712" cy="1754326"/>
           </a:xfrm>
           <a:prstGeom prst="rect">
             <a:avLst/>
@@ -36776,7 +36776,7 @@
                 </a:solidFill>
                 <a:latin typeface="Consolas" panose="020B0609020204030204" pitchFamily="49" charset="0"/>
               </a:rPr>
-              <a:t>"Hello QA Apprenticeships"</a:t>
+              <a:t>"&lt;h3&gt;Hello QA Apprenticeships&lt;/h3&gt;"</a:t>
             </a:r>
             <a:r>
               <a:rPr lang="en-GB" sz="1800" b="1" dirty="0">
@@ -40314,6 +40314,32 @@
 </file>
 
 <file path=customXml/item1.xml><?xml version="1.0" encoding="utf-8"?>
+<p:properties xmlns:p="http://schemas.microsoft.com/office/2006/metadata/properties" xmlns:xsi="http://www.w3.org/2001/XMLSchema-instance" xmlns:pc="http://schemas.microsoft.com/office/infopath/2007/PartnerControls">
+  <documentManagement>
+    <BookTypeField0 xmlns="B42EA499-AA80-4ED5-9ED5-37A17D3EB549">
+      <Terms xmlns="http://schemas.microsoft.com/office/infopath/2007/PartnerControls">
+        <TermInfo xmlns="http://schemas.microsoft.com/office/infopath/2007/PartnerControls">
+          <TermName xmlns="http://schemas.microsoft.com/office/infopath/2007/PartnerControls">IK</TermName>
+          <TermId xmlns="http://schemas.microsoft.com/office/infopath/2007/PartnerControls">5abe6401-e87a-4499-80b4-3d21a1a6ebd7</TermId>
+        </TermInfo>
+      </Terms>
+    </BookTypeField0>
+    <IsBuildFile xmlns="B42EA499-AA80-4ED5-9ED5-37A17D3EB549" xsi:nil="true"/>
+    <SequenceNumber xmlns="B42EA499-AA80-4ED5-9ED5-37A17D3EB549" xsi:nil="true"/>
+  </documentManagement>
+</p:properties>
+</file>
+
+<file path=customXml/item2.xml><?xml version="1.0" encoding="utf-8"?>
+<?mso-contentType ?>
+<FormTemplates xmlns="http://schemas.microsoft.com/sharepoint/v3/contenttype/forms">
+  <Display>DocumentLibraryForm</Display>
+  <Edit>DocumentLibraryForm</Edit>
+  <New>DocumentLibraryForm</New>
+</FormTemplates>
+</file>
+
+<file path=customXml/item3.xml><?xml version="1.0" encoding="utf-8"?>
 <ct:contentTypeSchema xmlns:ct="http://schemas.microsoft.com/office/2006/metadata/contentType" xmlns:ma="http://schemas.microsoft.com/office/2006/metadata/properties/metaAttributes" ct:_="" ma:_="" ma:contentTypeName="Courseware" ma:contentTypeID="0x010100F0967B7CEE8D417F966757887D9466FB005CB7CECC996A5B448C70C3215DE65491" ma:contentTypeVersion="0" ma:contentTypeDescription="Base content type which represents courseware documents" ma:contentTypeScope="" ma:versionID="633ed7bf8a9769dc10b8af609c2e65e8">
   <xsd:schema xmlns:xsd="http://www.w3.org/2001/XMLSchema" xmlns:xs="http://www.w3.org/2001/XMLSchema" xmlns:p="http://schemas.microsoft.com/office/2006/metadata/properties" xmlns:ns2="B42EA499-AA80-4ED5-9ED5-37A17D3EB549" targetNamespace="http://schemas.microsoft.com/office/2006/metadata/properties" ma:root="true" ma:fieldsID="6641bdc0935a9ffdc34b1682c1e0febc" ns2:_="">
     <xsd:import namespace="B42EA499-AA80-4ED5-9ED5-37A17D3EB549"/>
@@ -40453,33 +40479,25 @@
 </ct:contentTypeSchema>
 </file>
 
-<file path=customXml/item2.xml><?xml version="1.0" encoding="utf-8"?>
-<?mso-contentType ?>
-<FormTemplates xmlns="http://schemas.microsoft.com/sharepoint/v3/contenttype/forms">
-  <Display>DocumentLibraryForm</Display>
-  <Edit>DocumentLibraryForm</Edit>
-  <New>DocumentLibraryForm</New>
-</FormTemplates>
+<file path=customXml/itemProps1.xml><?xml version="1.0" encoding="utf-8"?>
+<ds:datastoreItem xmlns:ds="http://schemas.openxmlformats.org/officeDocument/2006/customXml" ds:itemID="{6276D8A5-6460-41D8-B2BB-D6C022FE8A5C}">
+  <ds:schemaRefs>
+    <ds:schemaRef ds:uri="http://schemas.microsoft.com/office/2006/metadata/properties"/>
+    <ds:schemaRef ds:uri="http://schemas.microsoft.com/office/infopath/2007/PartnerControls"/>
+    <ds:schemaRef ds:uri="B42EA499-AA80-4ED5-9ED5-37A17D3EB549"/>
+  </ds:schemaRefs>
+</ds:datastoreItem>
 </file>
 
-<file path=customXml/item3.xml><?xml version="1.0" encoding="utf-8"?>
-<p:properties xmlns:p="http://schemas.microsoft.com/office/2006/metadata/properties" xmlns:xsi="http://www.w3.org/2001/XMLSchema-instance" xmlns:pc="http://schemas.microsoft.com/office/infopath/2007/PartnerControls">
-  <documentManagement>
-    <BookTypeField0 xmlns="B42EA499-AA80-4ED5-9ED5-37A17D3EB549">
-      <Terms xmlns="http://schemas.microsoft.com/office/infopath/2007/PartnerControls">
-        <TermInfo xmlns="http://schemas.microsoft.com/office/infopath/2007/PartnerControls">
-          <TermName xmlns="http://schemas.microsoft.com/office/infopath/2007/PartnerControls">IK</TermName>
-          <TermId xmlns="http://schemas.microsoft.com/office/infopath/2007/PartnerControls">5abe6401-e87a-4499-80b4-3d21a1a6ebd7</TermId>
-        </TermInfo>
-      </Terms>
-    </BookTypeField0>
-    <IsBuildFile xmlns="B42EA499-AA80-4ED5-9ED5-37A17D3EB549" xsi:nil="true"/>
-    <SequenceNumber xmlns="B42EA499-AA80-4ED5-9ED5-37A17D3EB549" xsi:nil="true"/>
-  </documentManagement>
-</p:properties>
+<file path=customXml/itemProps2.xml><?xml version="1.0" encoding="utf-8"?>
+<ds:datastoreItem xmlns:ds="http://schemas.openxmlformats.org/officeDocument/2006/customXml" ds:itemID="{D47B5C6E-C195-4668-928F-F519F583A6D4}">
+  <ds:schemaRefs>
+    <ds:schemaRef ds:uri="http://schemas.microsoft.com/sharepoint/v3/contenttype/forms"/>
+  </ds:schemaRefs>
+</ds:datastoreItem>
 </file>
 
-<file path=customXml/itemProps1.xml><?xml version="1.0" encoding="utf-8"?>
+<file path=customXml/itemProps3.xml><?xml version="1.0" encoding="utf-8"?>
 <ds:datastoreItem xmlns:ds="http://schemas.openxmlformats.org/officeDocument/2006/customXml" ds:itemID="{96C7C959-319B-49E2-8C8F-A5D510E8AE2E}">
   <ds:schemaRefs>
     <ds:schemaRef ds:uri="http://schemas.microsoft.com/office/2006/metadata/contentType"/>
@@ -40495,22 +40513,4 @@
     <ds:schemaRef ds:uri="http://schemas.microsoft.com/internal/obd"/>
   </ds:schemaRefs>
 </ds:datastoreItem>
-</file>
-
-<file path=customXml/itemProps2.xml><?xml version="1.0" encoding="utf-8"?>
-<ds:datastoreItem xmlns:ds="http://schemas.openxmlformats.org/officeDocument/2006/customXml" ds:itemID="{D47B5C6E-C195-4668-928F-F519F583A6D4}">
-  <ds:schemaRefs>
-    <ds:schemaRef ds:uri="http://schemas.microsoft.com/sharepoint/v3/contenttype/forms"/>
-  </ds:schemaRefs>
-</ds:datastoreItem>
-</file>
-
-<file path=customXml/itemProps3.xml><?xml version="1.0" encoding="utf-8"?>
-<ds:datastoreItem xmlns:ds="http://schemas.openxmlformats.org/officeDocument/2006/customXml" ds:itemID="{6276D8A5-6460-41D8-B2BB-D6C022FE8A5C}">
-  <ds:schemaRefs>
-    <ds:schemaRef ds:uri="http://schemas.microsoft.com/office/2006/metadata/properties"/>
-    <ds:schemaRef ds:uri="http://schemas.microsoft.com/office/infopath/2007/PartnerControls"/>
-    <ds:schemaRef ds:uri="B42EA499-AA80-4ED5-9ED5-37A17D3EB549"/>
-  </ds:schemaRefs>
-</ds:datastoreItem>
 </file>
</xml_diff>